<commit_message>
Update tests for slide font option
</commit_message>
<xml_diff>
--- a/tests/testthat/multi_slide_fullslide.pptx
+++ b/tests/testthat/multi_slide_fullslide.pptx
@@ -3489,8 +3489,8 @@
           </p:nvSpPr>
           <p:spPr>
             <a:xfrm>
-              <a:off x="793972" y="1877752"/>
-              <a:ext cx="10920451" cy="3812052"/>
+              <a:off x="797995" y="1877752"/>
+              <a:ext cx="10916428" cy="3814338"/>
             </a:xfrm>
             <a:prstGeom prst="rect">
               <a:avLst/>
@@ -3515,21 +3515,21 @@
           </p:nvSpPr>
           <p:spPr>
             <a:xfrm>
-              <a:off x="793972" y="5206846"/>
-              <a:ext cx="10920451" cy="0"/>
+              <a:off x="797995" y="5208842"/>
+              <a:ext cx="10916428" cy="0"/>
             </a:xfrm>
             <a:custGeom>
               <a:avLst/>
               <a:pathLst>
-                <a:path w="10920451" h="0">
+                <a:path w="10916428" h="0">
                   <a:moveTo>
                     <a:pt x="0" y="0"/>
                   </a:moveTo>
                   <a:lnTo>
-                    <a:pt x="10920451" y="0"/>
+                    <a:pt x="10916428" y="0"/>
                   </a:lnTo>
                   <a:lnTo>
-                    <a:pt x="10920451" y="0"/>
+                    <a:pt x="10916428" y="0"/>
                   </a:lnTo>
                 </a:path>
               </a:pathLst>
@@ -3558,21 +3558,21 @@
           </p:nvSpPr>
           <p:spPr>
             <a:xfrm>
-              <a:off x="793972" y="4469505"/>
-              <a:ext cx="10920451" cy="0"/>
+              <a:off x="797995" y="4471059"/>
+              <a:ext cx="10916428" cy="0"/>
             </a:xfrm>
             <a:custGeom>
               <a:avLst/>
               <a:pathLst>
-                <a:path w="10920451" h="0">
+                <a:path w="10916428" h="0">
                   <a:moveTo>
                     <a:pt x="0" y="0"/>
                   </a:moveTo>
                   <a:lnTo>
-                    <a:pt x="10920451" y="0"/>
+                    <a:pt x="10916428" y="0"/>
                   </a:lnTo>
                   <a:lnTo>
-                    <a:pt x="10920451" y="0"/>
+                    <a:pt x="10916428" y="0"/>
                   </a:lnTo>
                 </a:path>
               </a:pathLst>
@@ -3601,21 +3601,21 @@
           </p:nvSpPr>
           <p:spPr>
             <a:xfrm>
-              <a:off x="793972" y="3732164"/>
-              <a:ext cx="10920451" cy="0"/>
+              <a:off x="797995" y="3733276"/>
+              <a:ext cx="10916428" cy="0"/>
             </a:xfrm>
             <a:custGeom>
               <a:avLst/>
               <a:pathLst>
-                <a:path w="10920451" h="0">
+                <a:path w="10916428" h="0">
                   <a:moveTo>
                     <a:pt x="0" y="0"/>
                   </a:moveTo>
                   <a:lnTo>
-                    <a:pt x="10920451" y="0"/>
+                    <a:pt x="10916428" y="0"/>
                   </a:lnTo>
                   <a:lnTo>
-                    <a:pt x="10920451" y="0"/>
+                    <a:pt x="10916428" y="0"/>
                   </a:lnTo>
                 </a:path>
               </a:pathLst>
@@ -3644,21 +3644,21 @@
           </p:nvSpPr>
           <p:spPr>
             <a:xfrm>
-              <a:off x="793972" y="2994823"/>
-              <a:ext cx="10920451" cy="0"/>
+              <a:off x="797995" y="2995493"/>
+              <a:ext cx="10916428" cy="0"/>
             </a:xfrm>
             <a:custGeom>
               <a:avLst/>
               <a:pathLst>
-                <a:path w="10920451" h="0">
+                <a:path w="10916428" h="0">
                   <a:moveTo>
                     <a:pt x="0" y="0"/>
                   </a:moveTo>
                   <a:lnTo>
-                    <a:pt x="10920451" y="0"/>
+                    <a:pt x="10916428" y="0"/>
                   </a:lnTo>
                   <a:lnTo>
-                    <a:pt x="10920451" y="0"/>
+                    <a:pt x="10916428" y="0"/>
                   </a:lnTo>
                 </a:path>
               </a:pathLst>
@@ -3687,21 +3687,21 @@
           </p:nvSpPr>
           <p:spPr>
             <a:xfrm>
-              <a:off x="793972" y="2257482"/>
-              <a:ext cx="10920451" cy="0"/>
+              <a:off x="797995" y="2257710"/>
+              <a:ext cx="10916428" cy="0"/>
             </a:xfrm>
             <a:custGeom>
               <a:avLst/>
               <a:pathLst>
-                <a:path w="10920451" h="0">
+                <a:path w="10916428" h="0">
                   <a:moveTo>
                     <a:pt x="0" y="0"/>
                   </a:moveTo>
                   <a:lnTo>
-                    <a:pt x="10920451" y="0"/>
+                    <a:pt x="10916428" y="0"/>
                   </a:lnTo>
                   <a:lnTo>
-                    <a:pt x="10920451" y="0"/>
+                    <a:pt x="10916428" y="0"/>
                   </a:lnTo>
                 </a:path>
               </a:pathLst>
@@ -3730,15 +3730,15 @@
           </p:nvSpPr>
           <p:spPr>
             <a:xfrm>
-              <a:off x="1257357" y="1877752"/>
-              <a:ext cx="0" cy="3812052"/>
+              <a:off x="1261209" y="1877752"/>
+              <a:ext cx="0" cy="3814338"/>
             </a:xfrm>
             <a:custGeom>
               <a:avLst/>
               <a:pathLst>
-                <a:path w="0" h="3812052">
+                <a:path w="0" h="3814338">
                   <a:moveTo>
-                    <a:pt x="0" y="3812052"/>
+                    <a:pt x="0" y="3814338"/>
                   </a:moveTo>
                   <a:lnTo>
                     <a:pt x="0" y="0"/>
@@ -3773,15 +3773,15 @@
           </p:nvSpPr>
           <p:spPr>
             <a:xfrm>
-              <a:off x="3795757" y="1877752"/>
-              <a:ext cx="0" cy="3812052"/>
+              <a:off x="3798674" y="1877752"/>
+              <a:ext cx="0" cy="3814338"/>
             </a:xfrm>
             <a:custGeom>
               <a:avLst/>
               <a:pathLst>
-                <a:path w="0" h="3812052">
+                <a:path w="0" h="3814338">
                   <a:moveTo>
-                    <a:pt x="0" y="3812052"/>
+                    <a:pt x="0" y="3814338"/>
                   </a:moveTo>
                   <a:lnTo>
                     <a:pt x="0" y="0"/>
@@ -3816,15 +3816,15 @@
           </p:nvSpPr>
           <p:spPr>
             <a:xfrm>
-              <a:off x="6334157" y="1877752"/>
-              <a:ext cx="0" cy="3812052"/>
+              <a:off x="6336139" y="1877752"/>
+              <a:ext cx="0" cy="3814338"/>
             </a:xfrm>
             <a:custGeom>
               <a:avLst/>
               <a:pathLst>
-                <a:path w="0" h="3812052">
+                <a:path w="0" h="3814338">
                   <a:moveTo>
-                    <a:pt x="0" y="3812052"/>
+                    <a:pt x="0" y="3814338"/>
                   </a:moveTo>
                   <a:lnTo>
                     <a:pt x="0" y="0"/>
@@ -3859,15 +3859,15 @@
           </p:nvSpPr>
           <p:spPr>
             <a:xfrm>
-              <a:off x="8872557" y="1877752"/>
-              <a:ext cx="0" cy="3812052"/>
+              <a:off x="8873604" y="1877752"/>
+              <a:ext cx="0" cy="3814338"/>
             </a:xfrm>
             <a:custGeom>
               <a:avLst/>
               <a:pathLst>
-                <a:path w="0" h="3812052">
+                <a:path w="0" h="3814338">
                   <a:moveTo>
-                    <a:pt x="0" y="3812052"/>
+                    <a:pt x="0" y="3814338"/>
                   </a:moveTo>
                   <a:lnTo>
                     <a:pt x="0" y="0"/>
@@ -3902,15 +3902,15 @@
           </p:nvSpPr>
           <p:spPr>
             <a:xfrm>
-              <a:off x="11410958" y="1877752"/>
-              <a:ext cx="0" cy="3812052"/>
+              <a:off x="11411070" y="1877752"/>
+              <a:ext cx="0" cy="3814338"/>
             </a:xfrm>
             <a:custGeom>
               <a:avLst/>
               <a:pathLst>
-                <a:path w="0" h="3812052">
+                <a:path w="0" h="3814338">
                   <a:moveTo>
-                    <a:pt x="0" y="3812052"/>
+                    <a:pt x="0" y="3814338"/>
                   </a:moveTo>
                   <a:lnTo>
                     <a:pt x="0" y="0"/>
@@ -3945,21 +3945,21 @@
           </p:nvSpPr>
           <p:spPr>
             <a:xfrm>
-              <a:off x="793972" y="5575516"/>
-              <a:ext cx="10920451" cy="0"/>
+              <a:off x="797995" y="5577734"/>
+              <a:ext cx="10916428" cy="0"/>
             </a:xfrm>
             <a:custGeom>
               <a:avLst/>
               <a:pathLst>
-                <a:path w="10920451" h="0">
+                <a:path w="10916428" h="0">
                   <a:moveTo>
                     <a:pt x="0" y="0"/>
                   </a:moveTo>
                   <a:lnTo>
-                    <a:pt x="10920451" y="0"/>
+                    <a:pt x="10916428" y="0"/>
                   </a:lnTo>
                   <a:lnTo>
-                    <a:pt x="10920451" y="0"/>
+                    <a:pt x="10916428" y="0"/>
                   </a:lnTo>
                 </a:path>
               </a:pathLst>
@@ -3988,21 +3988,21 @@
           </p:nvSpPr>
           <p:spPr>
             <a:xfrm>
-              <a:off x="793972" y="4838175"/>
-              <a:ext cx="10920451" cy="0"/>
+              <a:off x="797995" y="4839951"/>
+              <a:ext cx="10916428" cy="0"/>
             </a:xfrm>
             <a:custGeom>
               <a:avLst/>
               <a:pathLst>
-                <a:path w="10920451" h="0">
+                <a:path w="10916428" h="0">
                   <a:moveTo>
                     <a:pt x="0" y="0"/>
                   </a:moveTo>
                   <a:lnTo>
-                    <a:pt x="10920451" y="0"/>
+                    <a:pt x="10916428" y="0"/>
                   </a:lnTo>
                   <a:lnTo>
-                    <a:pt x="10920451" y="0"/>
+                    <a:pt x="10916428" y="0"/>
                   </a:lnTo>
                 </a:path>
               </a:pathLst>
@@ -4031,21 +4031,21 @@
           </p:nvSpPr>
           <p:spPr>
             <a:xfrm>
-              <a:off x="793972" y="4100834"/>
-              <a:ext cx="10920451" cy="0"/>
+              <a:off x="797995" y="4102168"/>
+              <a:ext cx="10916428" cy="0"/>
             </a:xfrm>
             <a:custGeom>
               <a:avLst/>
               <a:pathLst>
-                <a:path w="10920451" h="0">
+                <a:path w="10916428" h="0">
                   <a:moveTo>
                     <a:pt x="0" y="0"/>
                   </a:moveTo>
                   <a:lnTo>
-                    <a:pt x="10920451" y="0"/>
+                    <a:pt x="10916428" y="0"/>
                   </a:lnTo>
                   <a:lnTo>
-                    <a:pt x="10920451" y="0"/>
+                    <a:pt x="10916428" y="0"/>
                   </a:lnTo>
                 </a:path>
               </a:pathLst>
@@ -4074,21 +4074,21 @@
           </p:nvSpPr>
           <p:spPr>
             <a:xfrm>
-              <a:off x="793972" y="3363494"/>
-              <a:ext cx="10920451" cy="0"/>
+              <a:off x="797995" y="3364384"/>
+              <a:ext cx="10916428" cy="0"/>
             </a:xfrm>
             <a:custGeom>
               <a:avLst/>
               <a:pathLst>
-                <a:path w="10920451" h="0">
+                <a:path w="10916428" h="0">
                   <a:moveTo>
                     <a:pt x="0" y="0"/>
                   </a:moveTo>
                   <a:lnTo>
-                    <a:pt x="10920451" y="0"/>
+                    <a:pt x="10916428" y="0"/>
                   </a:lnTo>
                   <a:lnTo>
-                    <a:pt x="10920451" y="0"/>
+                    <a:pt x="10916428" y="0"/>
                   </a:lnTo>
                 </a:path>
               </a:pathLst>
@@ -4117,21 +4117,21 @@
           </p:nvSpPr>
           <p:spPr>
             <a:xfrm>
-              <a:off x="793972" y="2626153"/>
-              <a:ext cx="10920451" cy="0"/>
+              <a:off x="797995" y="2626601"/>
+              <a:ext cx="10916428" cy="0"/>
             </a:xfrm>
             <a:custGeom>
               <a:avLst/>
               <a:pathLst>
-                <a:path w="10920451" h="0">
+                <a:path w="10916428" h="0">
                   <a:moveTo>
                     <a:pt x="0" y="0"/>
                   </a:moveTo>
                   <a:lnTo>
-                    <a:pt x="10920451" y="0"/>
+                    <a:pt x="10916428" y="0"/>
                   </a:lnTo>
                   <a:lnTo>
-                    <a:pt x="10920451" y="0"/>
+                    <a:pt x="10916428" y="0"/>
                   </a:lnTo>
                 </a:path>
               </a:pathLst>
@@ -4160,21 +4160,21 @@
           </p:nvSpPr>
           <p:spPr>
             <a:xfrm>
-              <a:off x="793972" y="1888812"/>
-              <a:ext cx="10920451" cy="0"/>
+              <a:off x="797995" y="1888818"/>
+              <a:ext cx="10916428" cy="0"/>
             </a:xfrm>
             <a:custGeom>
               <a:avLst/>
               <a:pathLst>
-                <a:path w="10920451" h="0">
+                <a:path w="10916428" h="0">
                   <a:moveTo>
                     <a:pt x="0" y="0"/>
                   </a:moveTo>
                   <a:lnTo>
-                    <a:pt x="10920451" y="0"/>
+                    <a:pt x="10916428" y="0"/>
                   </a:lnTo>
                   <a:lnTo>
-                    <a:pt x="10920451" y="0"/>
+                    <a:pt x="10916428" y="0"/>
                   </a:lnTo>
                 </a:path>
               </a:pathLst>
@@ -4203,15 +4203,15 @@
           </p:nvSpPr>
           <p:spPr>
             <a:xfrm>
-              <a:off x="2526557" y="1877752"/>
-              <a:ext cx="0" cy="3812052"/>
+              <a:off x="2529942" y="1877752"/>
+              <a:ext cx="0" cy="3814338"/>
             </a:xfrm>
             <a:custGeom>
               <a:avLst/>
               <a:pathLst>
-                <a:path w="0" h="3812052">
+                <a:path w="0" h="3814338">
                   <a:moveTo>
-                    <a:pt x="0" y="3812052"/>
+                    <a:pt x="0" y="3814338"/>
                   </a:moveTo>
                   <a:lnTo>
                     <a:pt x="0" y="0"/>
@@ -4246,15 +4246,15 @@
           </p:nvSpPr>
           <p:spPr>
             <a:xfrm>
-              <a:off x="5064957" y="1877752"/>
-              <a:ext cx="0" cy="3812052"/>
+              <a:off x="5067407" y="1877752"/>
+              <a:ext cx="0" cy="3814338"/>
             </a:xfrm>
             <a:custGeom>
               <a:avLst/>
               <a:pathLst>
-                <a:path w="0" h="3812052">
+                <a:path w="0" h="3814338">
                   <a:moveTo>
-                    <a:pt x="0" y="3812052"/>
+                    <a:pt x="0" y="3814338"/>
                   </a:moveTo>
                   <a:lnTo>
                     <a:pt x="0" y="0"/>
@@ -4289,15 +4289,15 @@
           </p:nvSpPr>
           <p:spPr>
             <a:xfrm>
-              <a:off x="7603357" y="1877752"/>
-              <a:ext cx="0" cy="3812052"/>
+              <a:off x="7604872" y="1877752"/>
+              <a:ext cx="0" cy="3814338"/>
             </a:xfrm>
             <a:custGeom>
               <a:avLst/>
               <a:pathLst>
-                <a:path w="0" h="3812052">
+                <a:path w="0" h="3814338">
                   <a:moveTo>
-                    <a:pt x="0" y="3812052"/>
+                    <a:pt x="0" y="3814338"/>
                   </a:moveTo>
                   <a:lnTo>
                     <a:pt x="0" y="0"/>
@@ -4332,15 +4332,15 @@
           </p:nvSpPr>
           <p:spPr>
             <a:xfrm>
-              <a:off x="10141758" y="1877752"/>
-              <a:ext cx="0" cy="3812052"/>
+              <a:off x="10142337" y="1877752"/>
+              <a:ext cx="0" cy="3814338"/>
             </a:xfrm>
             <a:custGeom>
               <a:avLst/>
               <a:pathLst>
-                <a:path w="0" h="3812052">
+                <a:path w="0" h="3814338">
                   <a:moveTo>
-                    <a:pt x="0" y="3812052"/>
+                    <a:pt x="0" y="3814338"/>
                   </a:moveTo>
                   <a:lnTo>
                     <a:pt x="0" y="0"/>
@@ -4375,7 +4375,7 @@
           </p:nvSpPr>
           <p:spPr>
             <a:xfrm>
-              <a:off x="4067290" y="3920291"/>
+              <a:off x="4070095" y="3921536"/>
               <a:ext cx="66150" cy="66150"/>
             </a:xfrm>
             <a:prstGeom prst="ellipse">
@@ -4410,7 +4410,7 @@
           </p:nvSpPr>
           <p:spPr>
             <a:xfrm>
-              <a:off x="4714582" y="3920291"/>
+              <a:off x="4717149" y="3921536"/>
               <a:ext cx="66150" cy="66150"/>
             </a:xfrm>
             <a:prstGeom prst="ellipse">
@@ -4445,7 +4445,7 @@
           </p:nvSpPr>
           <p:spPr>
             <a:xfrm>
-              <a:off x="3305770" y="3654849"/>
+              <a:off x="3308856" y="3655934"/>
               <a:ext cx="66150" cy="66150"/>
             </a:xfrm>
             <a:prstGeom prst="ellipse">
@@ -4480,7 +4480,7 @@
           </p:nvSpPr>
           <p:spPr>
             <a:xfrm>
-              <a:off x="5577638" y="3861304"/>
+              <a:off x="5579887" y="3862513"/>
               <a:ext cx="66150" cy="66150"/>
             </a:xfrm>
             <a:prstGeom prst="ellipse">
@@ -4515,7 +4515,7 @@
           </p:nvSpPr>
           <p:spPr>
             <a:xfrm>
-              <a:off x="6148778" y="4259468"/>
+              <a:off x="6150816" y="4260916"/>
               <a:ext cx="66150" cy="66150"/>
             </a:xfrm>
             <a:prstGeom prst="ellipse">
@@ -4550,7 +4550,7 @@
           </p:nvSpPr>
           <p:spPr>
             <a:xfrm>
-              <a:off x="6199546" y="4347949"/>
+              <a:off x="6201566" y="4349450"/>
               <a:ext cx="66150" cy="66150"/>
             </a:xfrm>
             <a:prstGeom prst="ellipse">
@@ -4585,7 +4585,7 @@
           </p:nvSpPr>
           <p:spPr>
             <a:xfrm>
-              <a:off x="6478770" y="4908328"/>
+              <a:off x="6480687" y="4910165"/>
               <a:ext cx="66150" cy="66150"/>
             </a:xfrm>
             <a:prstGeom prst="ellipse">
@@ -4620,7 +4620,7 @@
           </p:nvSpPr>
           <p:spPr>
             <a:xfrm>
-              <a:off x="5514178" y="3418899"/>
+              <a:off x="5516450" y="3419843"/>
               <a:ext cx="66150" cy="66150"/>
             </a:xfrm>
             <a:prstGeom prst="ellipse">
@@ -4655,7 +4655,7 @@
           </p:nvSpPr>
           <p:spPr>
             <a:xfrm>
-              <a:off x="5412642" y="3654849"/>
+              <a:off x="5414952" y="3655934"/>
               <a:ext cx="66150" cy="66150"/>
             </a:xfrm>
             <a:prstGeom prst="ellipse">
@@ -4690,7 +4690,7 @@
           </p:nvSpPr>
           <p:spPr>
             <a:xfrm>
-              <a:off x="6148778" y="4185734"/>
+              <a:off x="6150816" y="4187138"/>
               <a:ext cx="66150" cy="66150"/>
             </a:xfrm>
             <a:prstGeom prst="ellipse">
@@ -4725,7 +4725,7 @@
           </p:nvSpPr>
           <p:spPr>
             <a:xfrm>
-              <a:off x="6148778" y="4392189"/>
+              <a:off x="6150816" y="4393717"/>
               <a:ext cx="66150" cy="66150"/>
             </a:xfrm>
             <a:prstGeom prst="ellipse">
@@ -4760,7 +4760,7 @@
           </p:nvSpPr>
           <p:spPr>
             <a:xfrm>
-              <a:off x="7747970" y="4598645"/>
+              <a:off x="7749419" y="4600296"/>
               <a:ext cx="66150" cy="66150"/>
             </a:xfrm>
             <a:prstGeom prst="ellipse">
@@ -4795,7 +4795,7 @@
           </p:nvSpPr>
           <p:spPr>
             <a:xfrm>
-              <a:off x="6884914" y="4465924"/>
+              <a:off x="6886681" y="4467495"/>
               <a:ext cx="66150" cy="66150"/>
             </a:xfrm>
             <a:prstGeom prst="ellipse">
@@ -4830,7 +4830,7 @@
           </p:nvSpPr>
           <p:spPr>
             <a:xfrm>
-              <a:off x="7011834" y="4775607"/>
+              <a:off x="7013555" y="4777364"/>
               <a:ext cx="66150" cy="66150"/>
             </a:xfrm>
             <a:prstGeom prst="ellipse">
@@ -4865,7 +4865,7 @@
           </p:nvSpPr>
           <p:spPr>
             <a:xfrm>
-              <a:off x="10743283" y="5483454"/>
+              <a:off x="10743628" y="5485636"/>
               <a:ext cx="66150" cy="66150"/>
             </a:xfrm>
             <a:prstGeom prst="ellipse">
@@ -4900,7 +4900,7 @@
           </p:nvSpPr>
           <p:spPr>
             <a:xfrm>
-              <a:off x="11184964" y="5483454"/>
+              <a:off x="11185147" y="5485636"/>
               <a:ext cx="66150" cy="66150"/>
             </a:xfrm>
             <a:prstGeom prst="ellipse">
@@ -4935,7 +4935,7 @@
           </p:nvSpPr>
           <p:spPr>
             <a:xfrm>
-              <a:off x="10984431" y="4849341"/>
+              <a:off x="10984687" y="4851143"/>
               <a:ext cx="66150" cy="66150"/>
             </a:xfrm>
             <a:prstGeom prst="ellipse">
@@ -4970,7 +4970,7 @@
           </p:nvSpPr>
           <p:spPr>
             <a:xfrm>
-              <a:off x="3001162" y="2239154"/>
+              <a:off x="3004360" y="2239390"/>
               <a:ext cx="66150" cy="66150"/>
             </a:xfrm>
             <a:prstGeom prst="ellipse">
@@ -5005,7 +5005,7 @@
           </p:nvSpPr>
           <p:spPr>
             <a:xfrm>
-              <a:off x="1516198" y="2534090"/>
+              <a:off x="1519943" y="2534504"/>
               <a:ext cx="66150" cy="66150"/>
             </a:xfrm>
             <a:prstGeom prst="ellipse">
@@ -5040,7 +5040,7 @@
           </p:nvSpPr>
           <p:spPr>
             <a:xfrm>
-              <a:off x="2074646" y="2017952"/>
+              <a:off x="2078185" y="2018056"/>
               <a:ext cx="66150" cy="66150"/>
             </a:xfrm>
             <a:prstGeom prst="ellipse">
@@ -5075,7 +5075,7 @@
           </p:nvSpPr>
           <p:spPr>
             <a:xfrm>
-              <a:off x="3673838" y="3846557"/>
+              <a:off x="3676788" y="3847758"/>
               <a:ext cx="66150" cy="66150"/>
             </a:xfrm>
             <a:prstGeom prst="ellipse">
@@ -5110,7 +5110,7 @@
           </p:nvSpPr>
           <p:spPr>
             <a:xfrm>
-              <a:off x="6351850" y="4731366"/>
+              <a:off x="6353814" y="4733097"/>
               <a:ext cx="66150" cy="66150"/>
             </a:xfrm>
             <a:prstGeom prst="ellipse">
@@ -5145,7 +5145,7 @@
           </p:nvSpPr>
           <p:spPr>
             <a:xfrm>
-              <a:off x="6136086" y="4775607"/>
+              <a:off x="6138129" y="4777364"/>
               <a:ext cx="66150" cy="66150"/>
             </a:xfrm>
             <a:prstGeom prst="ellipse">
@@ -5180,7 +5180,7 @@
           </p:nvSpPr>
           <p:spPr>
             <a:xfrm>
-              <a:off x="7164138" y="5055796"/>
+              <a:off x="7165802" y="5057722"/>
               <a:ext cx="66150" cy="66150"/>
             </a:xfrm>
             <a:prstGeom prst="ellipse">
@@ -5215,7 +5215,7 @@
           </p:nvSpPr>
           <p:spPr>
             <a:xfrm>
-              <a:off x="7176830" y="4185734"/>
+              <a:off x="7178490" y="4187138"/>
               <a:ext cx="66150" cy="66150"/>
             </a:xfrm>
             <a:prstGeom prst="ellipse">
@@ -5250,7 +5250,7 @@
           </p:nvSpPr>
           <p:spPr>
             <a:xfrm>
-              <a:off x="2328486" y="2991242"/>
+              <a:off x="2331931" y="2991929"/>
               <a:ext cx="66150" cy="66150"/>
             </a:xfrm>
             <a:prstGeom prst="ellipse">
@@ -5285,7 +5285,7 @@
           </p:nvSpPr>
           <p:spPr>
             <a:xfrm>
-              <a:off x="2848858" y="3182950"/>
+              <a:off x="2852112" y="3183753"/>
               <a:ext cx="66150" cy="66150"/>
             </a:xfrm>
             <a:prstGeom prst="ellipse">
@@ -5320,7 +5320,7 @@
           </p:nvSpPr>
           <p:spPr>
             <a:xfrm>
-              <a:off x="1257281" y="2534090"/>
+              <a:off x="1261121" y="2534504"/>
               <a:ext cx="66150" cy="66150"/>
             </a:xfrm>
             <a:prstGeom prst="ellipse">
@@ -5355,7 +5355,7 @@
           </p:nvSpPr>
           <p:spPr>
             <a:xfrm>
-              <a:off x="5463410" y="4687126"/>
+              <a:off x="5465701" y="4688830"/>
               <a:ext cx="66150" cy="66150"/>
             </a:xfrm>
             <a:prstGeom prst="ellipse">
@@ -5390,7 +5390,7 @@
           </p:nvSpPr>
           <p:spPr>
             <a:xfrm>
-              <a:off x="4448050" y="4112000"/>
+              <a:off x="4450715" y="4113360"/>
               <a:ext cx="66150" cy="66150"/>
             </a:xfrm>
             <a:prstGeom prst="ellipse">
@@ -5425,7 +5425,7 @@
           </p:nvSpPr>
           <p:spPr>
             <a:xfrm>
-              <a:off x="6478770" y="4805100"/>
+              <a:off x="6480687" y="4806876"/>
               <a:ext cx="66150" cy="66150"/>
             </a:xfrm>
             <a:prstGeom prst="ellipse">
@@ -5460,7 +5460,7 @@
           </p:nvSpPr>
           <p:spPr>
             <a:xfrm>
-              <a:off x="4473434" y="3861304"/>
+              <a:off x="4476089" y="3862513"/>
               <a:ext cx="66150" cy="66150"/>
             </a:xfrm>
             <a:prstGeom prst="ellipse">
@@ -5495,8 +5495,8 @@
           </p:nvSpPr>
           <p:spPr>
             <a:xfrm>
-              <a:off x="606983" y="5535466"/>
-              <a:ext cx="124358" cy="80101"/>
+              <a:off x="605703" y="5538186"/>
+              <a:ext cx="129661" cy="79095"/>
             </a:xfrm>
             <a:prstGeom prst="rect">
               <a:avLst/>
@@ -5525,8 +5525,8 @@
                       <a:alpha val="100000"/>
                     </a:srgbClr>
                   </a:solidFill>
-                  <a:latin typeface="Helvetica"/>
-                  <a:cs typeface="Helvetica"/>
+                  <a:latin typeface="Avenir Next"/>
+                  <a:cs typeface="Avenir Next"/>
                 </a:rPr>
                 <a:t>10</a:t>
               </a:r>
@@ -5541,8 +5541,8 @@
           </p:nvSpPr>
           <p:spPr>
             <a:xfrm>
-              <a:off x="606983" y="4798125"/>
-              <a:ext cx="124358" cy="80101"/>
+              <a:off x="605703" y="4800403"/>
+              <a:ext cx="129661" cy="79095"/>
             </a:xfrm>
             <a:prstGeom prst="rect">
               <a:avLst/>
@@ -5571,8 +5571,8 @@
                       <a:alpha val="100000"/>
                     </a:srgbClr>
                   </a:solidFill>
-                  <a:latin typeface="Helvetica"/>
-                  <a:cs typeface="Helvetica"/>
+                  <a:latin typeface="Avenir Next"/>
+                  <a:cs typeface="Avenir Next"/>
                 </a:rPr>
                 <a:t>15</a:t>
               </a:r>
@@ -5587,8 +5587,8 @@
           </p:nvSpPr>
           <p:spPr>
             <a:xfrm>
-              <a:off x="606983" y="4060784"/>
-              <a:ext cx="124358" cy="80101"/>
+              <a:off x="605703" y="4062620"/>
+              <a:ext cx="129661" cy="79095"/>
             </a:xfrm>
             <a:prstGeom prst="rect">
               <a:avLst/>
@@ -5617,8 +5617,8 @@
                       <a:alpha val="100000"/>
                     </a:srgbClr>
                   </a:solidFill>
-                  <a:latin typeface="Helvetica"/>
-                  <a:cs typeface="Helvetica"/>
+                  <a:latin typeface="Avenir Next"/>
+                  <a:cs typeface="Avenir Next"/>
                 </a:rPr>
                 <a:t>20</a:t>
               </a:r>
@@ -5633,8 +5633,8 @@
           </p:nvSpPr>
           <p:spPr>
             <a:xfrm>
-              <a:off x="606983" y="3323443"/>
-              <a:ext cx="124358" cy="80101"/>
+              <a:off x="605703" y="3324837"/>
+              <a:ext cx="129661" cy="79095"/>
             </a:xfrm>
             <a:prstGeom prst="rect">
               <a:avLst/>
@@ -5663,8 +5663,8 @@
                       <a:alpha val="100000"/>
                     </a:srgbClr>
                   </a:solidFill>
-                  <a:latin typeface="Helvetica"/>
-                  <a:cs typeface="Helvetica"/>
+                  <a:latin typeface="Avenir Next"/>
+                  <a:cs typeface="Avenir Next"/>
                 </a:rPr>
                 <a:t>25</a:t>
               </a:r>
@@ -5679,8 +5679,8 @@
           </p:nvSpPr>
           <p:spPr>
             <a:xfrm>
-              <a:off x="606983" y="2586102"/>
-              <a:ext cx="124358" cy="80101"/>
+              <a:off x="605703" y="2587054"/>
+              <a:ext cx="129661" cy="79095"/>
             </a:xfrm>
             <a:prstGeom prst="rect">
               <a:avLst/>
@@ -5709,8 +5709,8 @@
                       <a:alpha val="100000"/>
                     </a:srgbClr>
                   </a:solidFill>
-                  <a:latin typeface="Helvetica"/>
-                  <a:cs typeface="Helvetica"/>
+                  <a:latin typeface="Avenir Next"/>
+                  <a:cs typeface="Avenir Next"/>
                 </a:rPr>
                 <a:t>30</a:t>
               </a:r>
@@ -5725,8 +5725,8 @@
           </p:nvSpPr>
           <p:spPr>
             <a:xfrm>
-              <a:off x="606983" y="1848761"/>
-              <a:ext cx="124358" cy="80101"/>
+              <a:off x="605703" y="1849270"/>
+              <a:ext cx="129661" cy="79095"/>
             </a:xfrm>
             <a:prstGeom prst="rect">
               <a:avLst/>
@@ -5755,8 +5755,8 @@
                       <a:alpha val="100000"/>
                     </a:srgbClr>
                   </a:solidFill>
-                  <a:latin typeface="Helvetica"/>
-                  <a:cs typeface="Helvetica"/>
+                  <a:latin typeface="Avenir Next"/>
+                  <a:cs typeface="Avenir Next"/>
                 </a:rPr>
                 <a:t>35</a:t>
               </a:r>
@@ -5771,7 +5771,7 @@
           </p:nvSpPr>
           <p:spPr>
             <a:xfrm>
-              <a:off x="759177" y="5575516"/>
+              <a:off x="763200" y="5577734"/>
               <a:ext cx="34794" cy="0"/>
             </a:xfrm>
             <a:custGeom>
@@ -5811,7 +5811,7 @@
           </p:nvSpPr>
           <p:spPr>
             <a:xfrm>
-              <a:off x="759177" y="4838175"/>
+              <a:off x="763200" y="4839951"/>
               <a:ext cx="34794" cy="0"/>
             </a:xfrm>
             <a:custGeom>
@@ -5851,7 +5851,7 @@
           </p:nvSpPr>
           <p:spPr>
             <a:xfrm>
-              <a:off x="759177" y="4100834"/>
+              <a:off x="763200" y="4102168"/>
               <a:ext cx="34794" cy="0"/>
             </a:xfrm>
             <a:custGeom>
@@ -5891,7 +5891,7 @@
           </p:nvSpPr>
           <p:spPr>
             <a:xfrm>
-              <a:off x="759177" y="3363494"/>
+              <a:off x="763200" y="3364384"/>
               <a:ext cx="34794" cy="0"/>
             </a:xfrm>
             <a:custGeom>
@@ -5931,7 +5931,7 @@
           </p:nvSpPr>
           <p:spPr>
             <a:xfrm>
-              <a:off x="759177" y="2626153"/>
+              <a:off x="763200" y="2626601"/>
               <a:ext cx="34794" cy="0"/>
             </a:xfrm>
             <a:custGeom>
@@ -5971,7 +5971,7 @@
           </p:nvSpPr>
           <p:spPr>
             <a:xfrm>
-              <a:off x="759177" y="1888812"/>
+              <a:off x="763200" y="1888818"/>
               <a:ext cx="34794" cy="0"/>
             </a:xfrm>
             <a:custGeom>
@@ -6011,7 +6011,7 @@
           </p:nvSpPr>
           <p:spPr>
             <a:xfrm>
-              <a:off x="2526557" y="5689804"/>
+              <a:off x="2529942" y="5692090"/>
               <a:ext cx="0" cy="34794"/>
             </a:xfrm>
             <a:custGeom>
@@ -6051,7 +6051,7 @@
           </p:nvSpPr>
           <p:spPr>
             <a:xfrm>
-              <a:off x="5064957" y="5689804"/>
+              <a:off x="5067407" y="5692090"/>
               <a:ext cx="0" cy="34794"/>
             </a:xfrm>
             <a:custGeom>
@@ -6091,7 +6091,7 @@
           </p:nvSpPr>
           <p:spPr>
             <a:xfrm>
-              <a:off x="7603357" y="5689804"/>
+              <a:off x="7604872" y="5692090"/>
               <a:ext cx="0" cy="34794"/>
             </a:xfrm>
             <a:custGeom>
@@ -6131,7 +6131,7 @@
           </p:nvSpPr>
           <p:spPr>
             <a:xfrm>
-              <a:off x="10141758" y="5689804"/>
+              <a:off x="10142337" y="5692090"/>
               <a:ext cx="0" cy="34794"/>
             </a:xfrm>
             <a:custGeom>
@@ -6171,8 +6171,8 @@
           </p:nvSpPr>
           <p:spPr>
             <a:xfrm>
-              <a:off x="2495467" y="5752434"/>
-              <a:ext cx="62179" cy="80101"/>
+              <a:off x="2497526" y="5754720"/>
+              <a:ext cx="64830" cy="79095"/>
             </a:xfrm>
             <a:prstGeom prst="rect">
               <a:avLst/>
@@ -6201,8 +6201,8 @@
                       <a:alpha val="100000"/>
                     </a:srgbClr>
                   </a:solidFill>
-                  <a:latin typeface="Helvetica"/>
-                  <a:cs typeface="Helvetica"/>
+                  <a:latin typeface="Avenir Next"/>
+                  <a:cs typeface="Avenir Next"/>
                 </a:rPr>
                 <a:t>2</a:t>
               </a:r>
@@ -6217,8 +6217,8 @@
           </p:nvSpPr>
           <p:spPr>
             <a:xfrm>
-              <a:off x="5033867" y="5752434"/>
-              <a:ext cx="62179" cy="80101"/>
+              <a:off x="5034991" y="5754720"/>
+              <a:ext cx="64830" cy="79095"/>
             </a:xfrm>
             <a:prstGeom prst="rect">
               <a:avLst/>
@@ -6247,8 +6247,8 @@
                       <a:alpha val="100000"/>
                     </a:srgbClr>
                   </a:solidFill>
-                  <a:latin typeface="Helvetica"/>
-                  <a:cs typeface="Helvetica"/>
+                  <a:latin typeface="Avenir Next"/>
+                  <a:cs typeface="Avenir Next"/>
                 </a:rPr>
                 <a:t>3</a:t>
               </a:r>
@@ -6263,8 +6263,8 @@
           </p:nvSpPr>
           <p:spPr>
             <a:xfrm>
-              <a:off x="7572268" y="5752434"/>
-              <a:ext cx="62179" cy="80101"/>
+              <a:off x="7572456" y="5754720"/>
+              <a:ext cx="64830" cy="79095"/>
             </a:xfrm>
             <a:prstGeom prst="rect">
               <a:avLst/>
@@ -6293,8 +6293,8 @@
                       <a:alpha val="100000"/>
                     </a:srgbClr>
                   </a:solidFill>
-                  <a:latin typeface="Helvetica"/>
-                  <a:cs typeface="Helvetica"/>
+                  <a:latin typeface="Avenir Next"/>
+                  <a:cs typeface="Avenir Next"/>
                 </a:rPr>
                 <a:t>4</a:t>
               </a:r>
@@ -6309,8 +6309,8 @@
           </p:nvSpPr>
           <p:spPr>
             <a:xfrm>
-              <a:off x="10110668" y="5752434"/>
-              <a:ext cx="62179" cy="80101"/>
+              <a:off x="10109921" y="5754720"/>
+              <a:ext cx="64830" cy="79095"/>
             </a:xfrm>
             <a:prstGeom prst="rect">
               <a:avLst/>
@@ -6339,8 +6339,8 @@
                       <a:alpha val="100000"/>
                     </a:srgbClr>
                   </a:solidFill>
-                  <a:latin typeface="Helvetica"/>
-                  <a:cs typeface="Helvetica"/>
+                  <a:latin typeface="Avenir Next"/>
+                  <a:cs typeface="Avenir Next"/>
                 </a:rPr>
                 <a:t>5</a:t>
               </a:r>
@@ -6355,8 +6355,8 @@
           </p:nvSpPr>
           <p:spPr>
             <a:xfrm>
-              <a:off x="6184383" y="5892110"/>
-              <a:ext cx="139628" cy="100218"/>
+              <a:off x="6181960" y="5893391"/>
+              <a:ext cx="148498" cy="98938"/>
             </a:xfrm>
             <a:prstGeom prst="rect">
               <a:avLst/>
@@ -6385,8 +6385,8 @@
                       <a:alpha val="100000"/>
                     </a:srgbClr>
                   </a:solidFill>
-                  <a:latin typeface="Helvetica"/>
-                  <a:cs typeface="Helvetica"/>
+                  <a:latin typeface="Avenir Next"/>
+                  <a:cs typeface="Avenir Next"/>
                 </a:rPr>
                 <a:t>wt</a:t>
               </a:r>
@@ -6401,8 +6401,8 @@
           </p:nvSpPr>
           <p:spPr>
             <a:xfrm rot="-5400000">
-              <a:off x="355247" y="3733669"/>
-              <a:ext cx="271851" cy="100218"/>
+              <a:off x="340342" y="3735452"/>
+              <a:ext cx="300380" cy="98938"/>
             </a:xfrm>
             <a:prstGeom prst="rect">
               <a:avLst/>
@@ -6431,8 +6431,8 @@
                       <a:alpha val="100000"/>
                     </a:srgbClr>
                   </a:solidFill>
-                  <a:latin typeface="Helvetica"/>
-                  <a:cs typeface="Helvetica"/>
+                  <a:latin typeface="Avenir Next"/>
+                  <a:cs typeface="Avenir Next"/>
                 </a:rPr>
                 <a:t>mpg</a:t>
               </a:r>
@@ -6595,8 +6595,8 @@
           </p:nvSpPr>
           <p:spPr>
             <a:xfrm>
-              <a:off x="576320" y="1899602"/>
-              <a:ext cx="11097964" cy="3556109"/>
+              <a:off x="581807" y="1899602"/>
+              <a:ext cx="11092477" cy="3560315"/>
             </a:xfrm>
             <a:prstGeom prst="rect">
               <a:avLst/>
@@ -6621,21 +6621,21 @@
           </p:nvSpPr>
           <p:spPr>
             <a:xfrm>
-              <a:off x="576320" y="4891517"/>
-              <a:ext cx="11097964" cy="0"/>
+              <a:off x="581807" y="4895056"/>
+              <a:ext cx="11092477" cy="0"/>
             </a:xfrm>
             <a:custGeom>
               <a:avLst/>
               <a:pathLst>
-                <a:path w="11097964" h="0">
+                <a:path w="11092477" h="0">
                   <a:moveTo>
                     <a:pt x="0" y="0"/>
                   </a:moveTo>
                   <a:lnTo>
-                    <a:pt x="11097964" y="0"/>
+                    <a:pt x="11092477" y="0"/>
                   </a:lnTo>
                   <a:lnTo>
-                    <a:pt x="11097964" y="0"/>
+                    <a:pt x="11092477" y="0"/>
                   </a:lnTo>
                 </a:path>
               </a:pathLst>
@@ -6664,21 +6664,21 @@
           </p:nvSpPr>
           <p:spPr>
             <a:xfrm>
-              <a:off x="576320" y="4064918"/>
-              <a:ext cx="11097964" cy="0"/>
+              <a:off x="581807" y="4067480"/>
+              <a:ext cx="11092477" cy="0"/>
             </a:xfrm>
             <a:custGeom>
               <a:avLst/>
               <a:pathLst>
-                <a:path w="11097964" h="0">
+                <a:path w="11092477" h="0">
                   <a:moveTo>
                     <a:pt x="0" y="0"/>
                   </a:moveTo>
                   <a:lnTo>
-                    <a:pt x="11097964" y="0"/>
+                    <a:pt x="11092477" y="0"/>
                   </a:lnTo>
                   <a:lnTo>
-                    <a:pt x="11097964" y="0"/>
+                    <a:pt x="11092477" y="0"/>
                   </a:lnTo>
                 </a:path>
               </a:pathLst>
@@ -6707,21 +6707,21 @@
           </p:nvSpPr>
           <p:spPr>
             <a:xfrm>
-              <a:off x="576320" y="3238320"/>
-              <a:ext cx="11097964" cy="0"/>
+              <a:off x="581807" y="3239903"/>
+              <a:ext cx="11092477" cy="0"/>
             </a:xfrm>
             <a:custGeom>
               <a:avLst/>
               <a:pathLst>
-                <a:path w="11097964" h="0">
+                <a:path w="11092477" h="0">
                   <a:moveTo>
                     <a:pt x="0" y="0"/>
                   </a:moveTo>
                   <a:lnTo>
-                    <a:pt x="11097964" y="0"/>
+                    <a:pt x="11092477" y="0"/>
                   </a:lnTo>
                   <a:lnTo>
-                    <a:pt x="11097964" y="0"/>
+                    <a:pt x="11092477" y="0"/>
                   </a:lnTo>
                 </a:path>
               </a:pathLst>
@@ -6750,21 +6750,21 @@
           </p:nvSpPr>
           <p:spPr>
             <a:xfrm>
-              <a:off x="576320" y="2411722"/>
-              <a:ext cx="11097964" cy="0"/>
+              <a:off x="581807" y="2412327"/>
+              <a:ext cx="11092477" cy="0"/>
             </a:xfrm>
             <a:custGeom>
               <a:avLst/>
               <a:pathLst>
-                <a:path w="11097964" h="0">
+                <a:path w="11092477" h="0">
                   <a:moveTo>
                     <a:pt x="0" y="0"/>
                   </a:moveTo>
                   <a:lnTo>
-                    <a:pt x="11097964" y="0"/>
+                    <a:pt x="11092477" y="0"/>
                   </a:lnTo>
                   <a:lnTo>
-                    <a:pt x="11097964" y="0"/>
+                    <a:pt x="11092477" y="0"/>
                   </a:lnTo>
                 </a:path>
               </a:pathLst>
@@ -6793,7 +6793,7 @@
           </p:nvSpPr>
           <p:spPr>
             <a:xfrm>
-              <a:off x="5598507" y="4345951"/>
+              <a:off x="5601495" y="4348884"/>
               <a:ext cx="66150" cy="66150"/>
             </a:xfrm>
             <a:prstGeom prst="ellipse">
@@ -6828,7 +6828,7 @@
           </p:nvSpPr>
           <p:spPr>
             <a:xfrm>
-              <a:off x="5598507" y="4135168"/>
+              <a:off x="5601495" y="4137852"/>
               <a:ext cx="66150" cy="66150"/>
             </a:xfrm>
             <a:prstGeom prst="ellipse">
@@ -6863,7 +6863,7 @@
           </p:nvSpPr>
           <p:spPr>
             <a:xfrm>
-              <a:off x="6371286" y="4593930"/>
+              <a:off x="6373892" y="4597156"/>
               <a:ext cx="66150" cy="66150"/>
             </a:xfrm>
             <a:prstGeom prst="ellipse">
@@ -6898,7 +6898,7 @@
           </p:nvSpPr>
           <p:spPr>
             <a:xfrm>
-              <a:off x="5770236" y="3854125"/>
+              <a:off x="5773139" y="3856476"/>
               <a:ext cx="66150" cy="66150"/>
             </a:xfrm>
             <a:prstGeom prst="ellipse">
@@ -6933,7 +6933,7 @@
           </p:nvSpPr>
           <p:spPr>
             <a:xfrm>
-              <a:off x="4611068" y="3668140"/>
+              <a:off x="4614543" y="3670271"/>
               <a:ext cx="66150" cy="66150"/>
             </a:xfrm>
             <a:prstGeom prst="ellipse">
@@ -6968,7 +6968,7 @@
           </p:nvSpPr>
           <p:spPr>
             <a:xfrm>
-              <a:off x="4353475" y="3651608"/>
+              <a:off x="4357078" y="3653720"/>
               <a:ext cx="66150" cy="66150"/>
             </a:xfrm>
             <a:prstGeom prst="ellipse">
@@ -7003,7 +7003,7 @@
           </p:nvSpPr>
           <p:spPr>
             <a:xfrm>
-              <a:off x="2722053" y="3560682"/>
+              <a:off x="2726462" y="3562686"/>
               <a:ext cx="66150" cy="66150"/>
             </a:xfrm>
             <a:prstGeom prst="ellipse">
@@ -7038,7 +7038,7 @@
           </p:nvSpPr>
           <p:spPr>
             <a:xfrm>
-              <a:off x="7058201" y="3874790"/>
+              <a:off x="7060467" y="3877165"/>
               <a:ext cx="66150" cy="66150"/>
             </a:xfrm>
             <a:prstGeom prst="ellipse">
@@ -7073,7 +7073,7 @@
           </p:nvSpPr>
           <p:spPr>
             <a:xfrm>
-              <a:off x="6371286" y="3907854"/>
+              <a:off x="6373892" y="3910268"/>
               <a:ext cx="66150" cy="66150"/>
             </a:xfrm>
             <a:prstGeom prst="ellipse">
@@ -7108,7 +7108,7 @@
           </p:nvSpPr>
           <p:spPr>
             <a:xfrm>
-              <a:off x="4825729" y="3668140"/>
+              <a:off x="4829098" y="3670271"/>
               <a:ext cx="66150" cy="66150"/>
             </a:xfrm>
             <a:prstGeom prst="ellipse">
@@ -7143,7 +7143,7 @@
           </p:nvSpPr>
           <p:spPr>
             <a:xfrm>
-              <a:off x="4224678" y="3668140"/>
+              <a:off x="4228345" y="3670271"/>
               <a:ext cx="66150" cy="66150"/>
             </a:xfrm>
             <a:prstGeom prst="ellipse">
@@ -7178,7 +7178,7 @@
           </p:nvSpPr>
           <p:spPr>
             <a:xfrm>
-              <a:off x="3623628" y="3147383"/>
+              <a:off x="3627592" y="3148898"/>
               <a:ext cx="66150" cy="66150"/>
             </a:xfrm>
             <a:prstGeom prst="ellipse">
@@ -7213,7 +7213,7 @@
           </p:nvSpPr>
           <p:spPr>
             <a:xfrm>
-              <a:off x="4010017" y="3428427"/>
+              <a:off x="4013790" y="3430274"/>
               <a:ext cx="66150" cy="66150"/>
             </a:xfrm>
             <a:prstGeom prst="ellipse">
@@ -7248,7 +7248,7 @@
           </p:nvSpPr>
           <p:spPr>
             <a:xfrm>
-              <a:off x="3108442" y="3387097"/>
+              <a:off x="3112660" y="3388895"/>
               <a:ext cx="66150" cy="66150"/>
             </a:xfrm>
             <a:prstGeom prst="ellipse">
@@ -7283,7 +7283,7 @@
           </p:nvSpPr>
           <p:spPr>
             <a:xfrm>
-              <a:off x="1047698" y="2171997"/>
+              <a:off x="1052935" y="2172358"/>
               <a:ext cx="66150" cy="66150"/>
             </a:xfrm>
             <a:prstGeom prst="ellipse">
@@ -7318,7 +7318,7 @@
           </p:nvSpPr>
           <p:spPr>
             <a:xfrm>
-              <a:off x="1047698" y="2028169"/>
+              <a:off x="1052935" y="2028360"/>
               <a:ext cx="66150" cy="66150"/>
             </a:xfrm>
             <a:prstGeom prst="ellipse">
@@ -7353,7 +7353,7 @@
           </p:nvSpPr>
           <p:spPr>
             <a:xfrm>
-              <a:off x="2893781" y="2093470"/>
+              <a:off x="2898106" y="2093739"/>
               <a:ext cx="66150" cy="66150"/>
             </a:xfrm>
             <a:prstGeom prst="ellipse">
@@ -7388,7 +7388,7 @@
           </p:nvSpPr>
           <p:spPr>
             <a:xfrm>
-              <a:off x="10492774" y="4693122"/>
+              <a:off x="10493342" y="4696466"/>
               <a:ext cx="66150" cy="66150"/>
             </a:xfrm>
             <a:prstGeom prst="ellipse">
@@ -7423,7 +7423,7 @@
           </p:nvSpPr>
           <p:spPr>
             <a:xfrm>
-              <a:off x="9634131" y="5176682"/>
+              <a:off x="9635123" y="5180598"/>
               <a:ext cx="66150" cy="66150"/>
             </a:xfrm>
             <a:prstGeom prst="ellipse">
@@ -7458,7 +7458,7 @@
           </p:nvSpPr>
           <p:spPr>
             <a:xfrm>
-              <a:off x="11136757" y="4994831"/>
+              <a:off x="11137006" y="4998531"/>
               <a:ext cx="66150" cy="66150"/>
             </a:xfrm>
             <a:prstGeom prst="ellipse">
@@ -7493,7 +7493,7 @@
           </p:nvSpPr>
           <p:spPr>
             <a:xfrm>
-              <a:off x="5813168" y="4474074"/>
+              <a:off x="5816049" y="4477158"/>
               <a:ext cx="66150" cy="66150"/>
             </a:xfrm>
             <a:prstGeom prst="ellipse">
@@ -7528,7 +7528,7 @@
           </p:nvSpPr>
           <p:spPr>
             <a:xfrm>
-              <a:off x="3237238" y="3602012"/>
+              <a:off x="3241393" y="3604065"/>
               <a:ext cx="66150" cy="66150"/>
             </a:xfrm>
             <a:prstGeom prst="ellipse">
@@ -7563,7 +7563,7 @@
           </p:nvSpPr>
           <p:spPr>
             <a:xfrm>
-              <a:off x="3108442" y="3672273"/>
+              <a:off x="3112660" y="3674409"/>
               <a:ext cx="66150" cy="66150"/>
             </a:xfrm>
             <a:prstGeom prst="ellipse">
@@ -7598,7 +7598,7 @@
           </p:nvSpPr>
           <p:spPr>
             <a:xfrm>
-              <a:off x="2292731" y="3337501"/>
+              <a:off x="2297352" y="3339241"/>
               <a:ext cx="66150" cy="66150"/>
             </a:xfrm>
             <a:prstGeom prst="ellipse">
@@ -7633,7 +7633,7 @@
           </p:nvSpPr>
           <p:spPr>
             <a:xfrm>
-              <a:off x="4825729" y="3333368"/>
+              <a:off x="4829098" y="3335103"/>
               <a:ext cx="66150" cy="66150"/>
             </a:xfrm>
             <a:prstGeom prst="ellipse">
@@ -7668,7 +7668,7 @@
           </p:nvSpPr>
           <p:spPr>
             <a:xfrm>
-              <a:off x="8303234" y="4912171"/>
+              <a:off x="8304884" y="4915773"/>
               <a:ext cx="66150" cy="66150"/>
             </a:xfrm>
             <a:prstGeom prst="ellipse">
@@ -7703,7 +7703,7 @@
           </p:nvSpPr>
           <p:spPr>
             <a:xfrm>
-              <a:off x="7745116" y="4742718"/>
+              <a:off x="7747042" y="4746120"/>
               <a:ext cx="66150" cy="66150"/>
             </a:xfrm>
             <a:prstGeom prst="ellipse">
@@ -7738,7 +7738,7 @@
           </p:nvSpPr>
           <p:spPr>
             <a:xfrm>
-              <a:off x="9634131" y="5260995"/>
+              <a:off x="9635123" y="5265010"/>
               <a:ext cx="66150" cy="66150"/>
             </a:xfrm>
             <a:prstGeom prst="ellipse">
@@ -7773,7 +7773,7 @@
           </p:nvSpPr>
           <p:spPr>
             <a:xfrm>
-              <a:off x="3366035" y="3891322"/>
+              <a:off x="3370126" y="3893717"/>
               <a:ext cx="66150" cy="66150"/>
             </a:xfrm>
             <a:prstGeom prst="ellipse">
@@ -7808,7 +7808,7 @@
           </p:nvSpPr>
           <p:spPr>
             <a:xfrm>
-              <a:off x="5040389" y="4221961"/>
+              <a:off x="5043653" y="4224747"/>
               <a:ext cx="66150" cy="66150"/>
             </a:xfrm>
             <a:prstGeom prst="ellipse">
@@ -7843,7 +7843,7 @@
           </p:nvSpPr>
           <p:spPr>
             <a:xfrm>
-              <a:off x="3022578" y="3560682"/>
+              <a:off x="3026838" y="3562686"/>
               <a:ext cx="66150" cy="66150"/>
             </a:xfrm>
             <a:prstGeom prst="ellipse">
@@ -7878,7 +7878,7 @@
           </p:nvSpPr>
           <p:spPr>
             <a:xfrm>
-              <a:off x="5770236" y="4213695"/>
+              <a:off x="5773139" y="4216471"/>
               <a:ext cx="66150" cy="66150"/>
             </a:xfrm>
             <a:prstGeom prst="ellipse">
@@ -7913,8 +7913,8 @@
           </p:nvSpPr>
           <p:spPr>
             <a:xfrm>
-              <a:off x="373303" y="4809541"/>
-              <a:ext cx="127101" cy="163951"/>
+              <a:off x="373303" y="4814131"/>
+              <a:ext cx="132588" cy="161848"/>
             </a:xfrm>
             <a:prstGeom prst="rect">
               <a:avLst/>
@@ -7943,8 +7943,8 @@
                       <a:alpha val="100000"/>
                     </a:srgbClr>
                   </a:solidFill>
-                  <a:latin typeface="Helvetica"/>
-                  <a:cs typeface="Helvetica"/>
+                  <a:latin typeface="Avenir Next"/>
+                  <a:cs typeface="Avenir Next"/>
                 </a:rPr>
                 <a:t>2</a:t>
               </a:r>
@@ -7959,8 +7959,8 @@
           </p:nvSpPr>
           <p:spPr>
             <a:xfrm>
-              <a:off x="373303" y="3982943"/>
-              <a:ext cx="127101" cy="163951"/>
+              <a:off x="373303" y="3986555"/>
+              <a:ext cx="132588" cy="161848"/>
             </a:xfrm>
             <a:prstGeom prst="rect">
               <a:avLst/>
@@ -7989,8 +7989,8 @@
                       <a:alpha val="100000"/>
                     </a:srgbClr>
                   </a:solidFill>
-                  <a:latin typeface="Helvetica"/>
-                  <a:cs typeface="Helvetica"/>
+                  <a:latin typeface="Avenir Next"/>
+                  <a:cs typeface="Avenir Next"/>
                 </a:rPr>
                 <a:t>3</a:t>
               </a:r>
@@ -8005,8 +8005,8 @@
           </p:nvSpPr>
           <p:spPr>
             <a:xfrm>
-              <a:off x="373303" y="3156344"/>
-              <a:ext cx="127101" cy="163951"/>
+              <a:off x="373303" y="3158979"/>
+              <a:ext cx="132588" cy="161848"/>
             </a:xfrm>
             <a:prstGeom prst="rect">
               <a:avLst/>
@@ -8035,8 +8035,8 @@
                       <a:alpha val="100000"/>
                     </a:srgbClr>
                   </a:solidFill>
-                  <a:latin typeface="Helvetica"/>
-                  <a:cs typeface="Helvetica"/>
+                  <a:latin typeface="Avenir Next"/>
+                  <a:cs typeface="Avenir Next"/>
                 </a:rPr>
                 <a:t>4</a:t>
               </a:r>
@@ -8051,8 +8051,8 @@
           </p:nvSpPr>
           <p:spPr>
             <a:xfrm>
-              <a:off x="373303" y="2329746"/>
-              <a:ext cx="127101" cy="163951"/>
+              <a:off x="373303" y="2331403"/>
+              <a:ext cx="132588" cy="161848"/>
             </a:xfrm>
             <a:prstGeom prst="rect">
               <a:avLst/>
@@ -8081,8 +8081,8 @@
                       <a:alpha val="100000"/>
                     </a:srgbClr>
                   </a:solidFill>
-                  <a:latin typeface="Helvetica"/>
-                  <a:cs typeface="Helvetica"/>
+                  <a:latin typeface="Avenir Next"/>
+                  <a:cs typeface="Avenir Next"/>
                 </a:rPr>
                 <a:t>5</a:t>
               </a:r>
@@ -8097,18 +8097,18 @@
           </p:nvSpPr>
           <p:spPr>
             <a:xfrm>
-              <a:off x="576320" y="5455712"/>
-              <a:ext cx="11097964" cy="0"/>
+              <a:off x="581807" y="5459918"/>
+              <a:ext cx="11092477" cy="0"/>
             </a:xfrm>
             <a:custGeom>
               <a:avLst/>
               <a:pathLst>
-                <a:path w="11097964" h="0">
+                <a:path w="11092477" h="0">
                   <a:moveTo>
                     <a:pt x="0" y="0"/>
                   </a:moveTo>
                   <a:lnTo>
-                    <a:pt x="11097964" y="0"/>
+                    <a:pt x="11092477" y="0"/>
                   </a:lnTo>
                 </a:path>
               </a:pathLst>
@@ -8137,7 +8137,7 @@
           </p:nvSpPr>
           <p:spPr>
             <a:xfrm>
-              <a:off x="909044" y="5455712"/>
+              <a:off x="914366" y="5459918"/>
               <a:ext cx="0" cy="56936"/>
             </a:xfrm>
             <a:custGeom>
@@ -8177,7 +8177,7 @@
           </p:nvSpPr>
           <p:spPr>
             <a:xfrm>
-              <a:off x="3055653" y="5455712"/>
+              <a:off x="3059913" y="5459918"/>
               <a:ext cx="0" cy="56936"/>
             </a:xfrm>
             <a:custGeom>
@@ -8217,7 +8217,7 @@
           </p:nvSpPr>
           <p:spPr>
             <a:xfrm>
-              <a:off x="5202261" y="5455712"/>
+              <a:off x="5205460" y="5459918"/>
               <a:ext cx="0" cy="56936"/>
             </a:xfrm>
             <a:custGeom>
@@ -8257,7 +8257,7 @@
           </p:nvSpPr>
           <p:spPr>
             <a:xfrm>
-              <a:off x="7348869" y="5455712"/>
+              <a:off x="7351007" y="5459918"/>
               <a:ext cx="0" cy="56936"/>
             </a:xfrm>
             <a:custGeom>
@@ -8297,7 +8297,7 @@
           </p:nvSpPr>
           <p:spPr>
             <a:xfrm>
-              <a:off x="9495477" y="5455712"/>
+              <a:off x="9496554" y="5459918"/>
               <a:ext cx="0" cy="56936"/>
             </a:xfrm>
             <a:custGeom>
@@ -8337,7 +8337,7 @@
           </p:nvSpPr>
           <p:spPr>
             <a:xfrm>
-              <a:off x="11642085" y="5455712"/>
+              <a:off x="11642101" y="5459918"/>
               <a:ext cx="0" cy="56936"/>
             </a:xfrm>
             <a:custGeom>
@@ -8377,8 +8377,8 @@
           </p:nvSpPr>
           <p:spPr>
             <a:xfrm>
-              <a:off x="781943" y="5588564"/>
-              <a:ext cx="254203" cy="163951"/>
+              <a:off x="781778" y="5592770"/>
+              <a:ext cx="265176" cy="161848"/>
             </a:xfrm>
             <a:prstGeom prst="rect">
               <a:avLst/>
@@ -8407,8 +8407,8 @@
                       <a:alpha val="100000"/>
                     </a:srgbClr>
                   </a:solidFill>
-                  <a:latin typeface="Helvetica"/>
-                  <a:cs typeface="Helvetica"/>
+                  <a:latin typeface="Avenir Next"/>
+                  <a:cs typeface="Avenir Next"/>
                 </a:rPr>
                 <a:t>10</a:t>
               </a:r>
@@ -8423,8 +8423,8 @@
           </p:nvSpPr>
           <p:spPr>
             <a:xfrm>
-              <a:off x="2928551" y="5588564"/>
-              <a:ext cx="254203" cy="163951"/>
+              <a:off x="2927325" y="5592770"/>
+              <a:ext cx="265176" cy="161848"/>
             </a:xfrm>
             <a:prstGeom prst="rect">
               <a:avLst/>
@@ -8453,8 +8453,8 @@
                       <a:alpha val="100000"/>
                     </a:srgbClr>
                   </a:solidFill>
-                  <a:latin typeface="Helvetica"/>
-                  <a:cs typeface="Helvetica"/>
+                  <a:latin typeface="Avenir Next"/>
+                  <a:cs typeface="Avenir Next"/>
                 </a:rPr>
                 <a:t>15</a:t>
               </a:r>
@@ -8469,8 +8469,8 @@
           </p:nvSpPr>
           <p:spPr>
             <a:xfrm>
-              <a:off x="5075159" y="5588564"/>
-              <a:ext cx="254203" cy="163951"/>
+              <a:off x="5072872" y="5592770"/>
+              <a:ext cx="265176" cy="161848"/>
             </a:xfrm>
             <a:prstGeom prst="rect">
               <a:avLst/>
@@ -8499,8 +8499,8 @@
                       <a:alpha val="100000"/>
                     </a:srgbClr>
                   </a:solidFill>
-                  <a:latin typeface="Helvetica"/>
-                  <a:cs typeface="Helvetica"/>
+                  <a:latin typeface="Avenir Next"/>
+                  <a:cs typeface="Avenir Next"/>
                 </a:rPr>
                 <a:t>20</a:t>
               </a:r>
@@ -8515,8 +8515,8 @@
           </p:nvSpPr>
           <p:spPr>
             <a:xfrm>
-              <a:off x="7221767" y="5588564"/>
-              <a:ext cx="254203" cy="163951"/>
+              <a:off x="7218419" y="5592770"/>
+              <a:ext cx="265176" cy="161848"/>
             </a:xfrm>
             <a:prstGeom prst="rect">
               <a:avLst/>
@@ -8545,8 +8545,8 @@
                       <a:alpha val="100000"/>
                     </a:srgbClr>
                   </a:solidFill>
-                  <a:latin typeface="Helvetica"/>
-                  <a:cs typeface="Helvetica"/>
+                  <a:latin typeface="Avenir Next"/>
+                  <a:cs typeface="Avenir Next"/>
                 </a:rPr>
                 <a:t>25</a:t>
               </a:r>
@@ -8561,8 +8561,8 @@
           </p:nvSpPr>
           <p:spPr>
             <a:xfrm>
-              <a:off x="9368376" y="5588564"/>
-              <a:ext cx="254203" cy="163951"/>
+              <a:off x="9363966" y="5592770"/>
+              <a:ext cx="265176" cy="161848"/>
             </a:xfrm>
             <a:prstGeom prst="rect">
               <a:avLst/>
@@ -8591,8 +8591,8 @@
                       <a:alpha val="100000"/>
                     </a:srgbClr>
                   </a:solidFill>
-                  <a:latin typeface="Helvetica"/>
-                  <a:cs typeface="Helvetica"/>
+                  <a:latin typeface="Avenir Next"/>
+                  <a:cs typeface="Avenir Next"/>
                 </a:rPr>
                 <a:t>30</a:t>
               </a:r>
@@ -8607,8 +8607,8 @@
           </p:nvSpPr>
           <p:spPr>
             <a:xfrm>
-              <a:off x="11514984" y="5588564"/>
-              <a:ext cx="254203" cy="163951"/>
+              <a:off x="11509513" y="5592770"/>
+              <a:ext cx="265176" cy="161848"/>
             </a:xfrm>
             <a:prstGeom prst="rect">
               <a:avLst/>
@@ -8637,8 +8637,8 @@
                       <a:alpha val="100000"/>
                     </a:srgbClr>
                   </a:solidFill>
-                  <a:latin typeface="Helvetica"/>
-                  <a:cs typeface="Helvetica"/>
+                  <a:latin typeface="Avenir Next"/>
+                  <a:cs typeface="Avenir Next"/>
                 </a:rPr>
                 <a:t>35</a:t>
               </a:r>
@@ -8653,8 +8653,8 @@
           </p:nvSpPr>
           <p:spPr>
             <a:xfrm>
-              <a:off x="5902966" y="5860018"/>
-              <a:ext cx="444672" cy="163951"/>
+              <a:off x="5882255" y="5862121"/>
+              <a:ext cx="491581" cy="161848"/>
             </a:xfrm>
             <a:prstGeom prst="rect">
               <a:avLst/>
@@ -8683,8 +8683,8 @@
                       <a:alpha val="100000"/>
                     </a:srgbClr>
                   </a:solidFill>
-                  <a:latin typeface="Helvetica"/>
-                  <a:cs typeface="Helvetica"/>
+                  <a:latin typeface="Avenir Next"/>
+                  <a:cs typeface="Avenir Next"/>
                 </a:rPr>
                 <a:t>mpg</a:t>
               </a:r>

</xml_diff>

<commit_message>
Update tests for recent changes
</commit_message>
<xml_diff>
--- a/tests/testthat/multi_slide_fullslide.pptx
+++ b/tests/testthat/multi_slide_fullslide.pptx
@@ -3489,8 +3489,8 @@
           </p:nvSpPr>
           <p:spPr>
             <a:xfrm>
-              <a:off x="797995" y="1877752"/>
-              <a:ext cx="10916428" cy="3814338"/>
+              <a:off x="800647" y="1877752"/>
+              <a:ext cx="10913776" cy="3809583"/>
             </a:xfrm>
             <a:prstGeom prst="rect">
               <a:avLst/>
@@ -3515,21 +3515,21 @@
           </p:nvSpPr>
           <p:spPr>
             <a:xfrm>
-              <a:off x="797995" y="5208842"/>
-              <a:ext cx="10916428" cy="0"/>
+              <a:off x="800647" y="5204690"/>
+              <a:ext cx="10913776" cy="0"/>
             </a:xfrm>
             <a:custGeom>
               <a:avLst/>
               <a:pathLst>
-                <a:path w="10916428" h="0">
+                <a:path w="10913776" h="0">
                   <a:moveTo>
                     <a:pt x="0" y="0"/>
                   </a:moveTo>
                   <a:lnTo>
-                    <a:pt x="10916428" y="0"/>
+                    <a:pt x="10913776" y="0"/>
                   </a:lnTo>
                   <a:lnTo>
-                    <a:pt x="10916428" y="0"/>
+                    <a:pt x="10913776" y="0"/>
                   </a:lnTo>
                 </a:path>
               </a:pathLst>
@@ -3558,21 +3558,21 @@
           </p:nvSpPr>
           <p:spPr>
             <a:xfrm>
-              <a:off x="797995" y="4471059"/>
-              <a:ext cx="10916428" cy="0"/>
+              <a:off x="800647" y="4467826"/>
+              <a:ext cx="10913776" cy="0"/>
             </a:xfrm>
             <a:custGeom>
               <a:avLst/>
               <a:pathLst>
-                <a:path w="10916428" h="0">
+                <a:path w="10913776" h="0">
                   <a:moveTo>
                     <a:pt x="0" y="0"/>
                   </a:moveTo>
                   <a:lnTo>
-                    <a:pt x="10916428" y="0"/>
+                    <a:pt x="10913776" y="0"/>
                   </a:lnTo>
                   <a:lnTo>
-                    <a:pt x="10916428" y="0"/>
+                    <a:pt x="10913776" y="0"/>
                   </a:lnTo>
                 </a:path>
               </a:pathLst>
@@ -3601,21 +3601,21 @@
           </p:nvSpPr>
           <p:spPr>
             <a:xfrm>
-              <a:off x="797995" y="3733276"/>
-              <a:ext cx="10916428" cy="0"/>
+              <a:off x="800647" y="3730963"/>
+              <a:ext cx="10913776" cy="0"/>
             </a:xfrm>
             <a:custGeom>
               <a:avLst/>
               <a:pathLst>
-                <a:path w="10916428" h="0">
+                <a:path w="10913776" h="0">
                   <a:moveTo>
                     <a:pt x="0" y="0"/>
                   </a:moveTo>
                   <a:lnTo>
-                    <a:pt x="10916428" y="0"/>
+                    <a:pt x="10913776" y="0"/>
                   </a:lnTo>
                   <a:lnTo>
-                    <a:pt x="10916428" y="0"/>
+                    <a:pt x="10913776" y="0"/>
                   </a:lnTo>
                 </a:path>
               </a:pathLst>
@@ -3644,21 +3644,21 @@
           </p:nvSpPr>
           <p:spPr>
             <a:xfrm>
-              <a:off x="797995" y="2995493"/>
-              <a:ext cx="10916428" cy="0"/>
+              <a:off x="800647" y="2994100"/>
+              <a:ext cx="10913776" cy="0"/>
             </a:xfrm>
             <a:custGeom>
               <a:avLst/>
               <a:pathLst>
-                <a:path w="10916428" h="0">
+                <a:path w="10913776" h="0">
                   <a:moveTo>
                     <a:pt x="0" y="0"/>
                   </a:moveTo>
                   <a:lnTo>
-                    <a:pt x="10916428" y="0"/>
+                    <a:pt x="10913776" y="0"/>
                   </a:lnTo>
                   <a:lnTo>
-                    <a:pt x="10916428" y="0"/>
+                    <a:pt x="10913776" y="0"/>
                   </a:lnTo>
                 </a:path>
               </a:pathLst>
@@ -3687,21 +3687,21 @@
           </p:nvSpPr>
           <p:spPr>
             <a:xfrm>
-              <a:off x="797995" y="2257710"/>
-              <a:ext cx="10916428" cy="0"/>
+              <a:off x="800647" y="2257236"/>
+              <a:ext cx="10913776" cy="0"/>
             </a:xfrm>
             <a:custGeom>
               <a:avLst/>
               <a:pathLst>
-                <a:path w="10916428" h="0">
+                <a:path w="10913776" h="0">
                   <a:moveTo>
                     <a:pt x="0" y="0"/>
                   </a:moveTo>
                   <a:lnTo>
-                    <a:pt x="10916428" y="0"/>
+                    <a:pt x="10913776" y="0"/>
                   </a:lnTo>
                   <a:lnTo>
-                    <a:pt x="10916428" y="0"/>
+                    <a:pt x="10913776" y="0"/>
                   </a:lnTo>
                 </a:path>
               </a:pathLst>
@@ -3730,15 +3730,15 @@
           </p:nvSpPr>
           <p:spPr>
             <a:xfrm>
-              <a:off x="1261209" y="1877752"/>
-              <a:ext cx="0" cy="3814338"/>
+              <a:off x="1263748" y="1877752"/>
+              <a:ext cx="0" cy="3809583"/>
             </a:xfrm>
             <a:custGeom>
               <a:avLst/>
               <a:pathLst>
-                <a:path w="0" h="3814338">
+                <a:path w="0" h="3809583">
                   <a:moveTo>
-                    <a:pt x="0" y="3814338"/>
+                    <a:pt x="0" y="3809583"/>
                   </a:moveTo>
                   <a:lnTo>
                     <a:pt x="0" y="0"/>
@@ -3773,15 +3773,15 @@
           </p:nvSpPr>
           <p:spPr>
             <a:xfrm>
-              <a:off x="3798674" y="1877752"/>
-              <a:ext cx="0" cy="3814338"/>
+              <a:off x="3800597" y="1877752"/>
+              <a:ext cx="0" cy="3809583"/>
             </a:xfrm>
             <a:custGeom>
               <a:avLst/>
               <a:pathLst>
-                <a:path w="0" h="3814338">
+                <a:path w="0" h="3809583">
                   <a:moveTo>
-                    <a:pt x="0" y="3814338"/>
+                    <a:pt x="0" y="3809583"/>
                   </a:moveTo>
                   <a:lnTo>
                     <a:pt x="0" y="0"/>
@@ -3816,15 +3816,15 @@
           </p:nvSpPr>
           <p:spPr>
             <a:xfrm>
-              <a:off x="6336139" y="1877752"/>
-              <a:ext cx="0" cy="3814338"/>
+              <a:off x="6337446" y="1877752"/>
+              <a:ext cx="0" cy="3809583"/>
             </a:xfrm>
             <a:custGeom>
               <a:avLst/>
               <a:pathLst>
-                <a:path w="0" h="3814338">
+                <a:path w="0" h="3809583">
                   <a:moveTo>
-                    <a:pt x="0" y="3814338"/>
+                    <a:pt x="0" y="3809583"/>
                   </a:moveTo>
                   <a:lnTo>
                     <a:pt x="0" y="0"/>
@@ -3859,15 +3859,15 @@
           </p:nvSpPr>
           <p:spPr>
             <a:xfrm>
-              <a:off x="8873604" y="1877752"/>
-              <a:ext cx="0" cy="3814338"/>
+              <a:off x="8874294" y="1877752"/>
+              <a:ext cx="0" cy="3809583"/>
             </a:xfrm>
             <a:custGeom>
               <a:avLst/>
               <a:pathLst>
-                <a:path w="0" h="3814338">
+                <a:path w="0" h="3809583">
                   <a:moveTo>
-                    <a:pt x="0" y="3814338"/>
+                    <a:pt x="0" y="3809583"/>
                   </a:moveTo>
                   <a:lnTo>
                     <a:pt x="0" y="0"/>
@@ -3902,15 +3902,15 @@
           </p:nvSpPr>
           <p:spPr>
             <a:xfrm>
-              <a:off x="11411070" y="1877752"/>
-              <a:ext cx="0" cy="3814338"/>
+              <a:off x="11411143" y="1877752"/>
+              <a:ext cx="0" cy="3809583"/>
             </a:xfrm>
             <a:custGeom>
               <a:avLst/>
               <a:pathLst>
-                <a:path w="0" h="3814338">
+                <a:path w="0" h="3809583">
                   <a:moveTo>
-                    <a:pt x="0" y="3814338"/>
+                    <a:pt x="0" y="3809583"/>
                   </a:moveTo>
                   <a:lnTo>
                     <a:pt x="0" y="0"/>
@@ -3945,21 +3945,21 @@
           </p:nvSpPr>
           <p:spPr>
             <a:xfrm>
-              <a:off x="797995" y="5577734"/>
-              <a:ext cx="10916428" cy="0"/>
+              <a:off x="800647" y="5573121"/>
+              <a:ext cx="10913776" cy="0"/>
             </a:xfrm>
             <a:custGeom>
               <a:avLst/>
               <a:pathLst>
-                <a:path w="10916428" h="0">
+                <a:path w="10913776" h="0">
                   <a:moveTo>
                     <a:pt x="0" y="0"/>
                   </a:moveTo>
                   <a:lnTo>
-                    <a:pt x="10916428" y="0"/>
+                    <a:pt x="10913776" y="0"/>
                   </a:lnTo>
                   <a:lnTo>
-                    <a:pt x="10916428" y="0"/>
+                    <a:pt x="10913776" y="0"/>
                   </a:lnTo>
                 </a:path>
               </a:pathLst>
@@ -3988,21 +3988,21 @@
           </p:nvSpPr>
           <p:spPr>
             <a:xfrm>
-              <a:off x="797995" y="4839951"/>
-              <a:ext cx="10916428" cy="0"/>
+              <a:off x="800647" y="4836258"/>
+              <a:ext cx="10913776" cy="0"/>
             </a:xfrm>
             <a:custGeom>
               <a:avLst/>
               <a:pathLst>
-                <a:path w="10916428" h="0">
+                <a:path w="10913776" h="0">
                   <a:moveTo>
                     <a:pt x="0" y="0"/>
                   </a:moveTo>
                   <a:lnTo>
-                    <a:pt x="10916428" y="0"/>
+                    <a:pt x="10913776" y="0"/>
                   </a:lnTo>
                   <a:lnTo>
-                    <a:pt x="10916428" y="0"/>
+                    <a:pt x="10913776" y="0"/>
                   </a:lnTo>
                 </a:path>
               </a:pathLst>
@@ -4031,21 +4031,21 @@
           </p:nvSpPr>
           <p:spPr>
             <a:xfrm>
-              <a:off x="797995" y="4102168"/>
-              <a:ext cx="10916428" cy="0"/>
+              <a:off x="800647" y="4099395"/>
+              <a:ext cx="10913776" cy="0"/>
             </a:xfrm>
             <a:custGeom>
               <a:avLst/>
               <a:pathLst>
-                <a:path w="10916428" h="0">
+                <a:path w="10913776" h="0">
                   <a:moveTo>
                     <a:pt x="0" y="0"/>
                   </a:moveTo>
                   <a:lnTo>
-                    <a:pt x="10916428" y="0"/>
+                    <a:pt x="10913776" y="0"/>
                   </a:lnTo>
                   <a:lnTo>
-                    <a:pt x="10916428" y="0"/>
+                    <a:pt x="10913776" y="0"/>
                   </a:lnTo>
                 </a:path>
               </a:pathLst>
@@ -4074,21 +4074,21 @@
           </p:nvSpPr>
           <p:spPr>
             <a:xfrm>
-              <a:off x="797995" y="3364384"/>
-              <a:ext cx="10916428" cy="0"/>
+              <a:off x="800647" y="3362531"/>
+              <a:ext cx="10913776" cy="0"/>
             </a:xfrm>
             <a:custGeom>
               <a:avLst/>
               <a:pathLst>
-                <a:path w="10916428" h="0">
+                <a:path w="10913776" h="0">
                   <a:moveTo>
                     <a:pt x="0" y="0"/>
                   </a:moveTo>
                   <a:lnTo>
-                    <a:pt x="10916428" y="0"/>
+                    <a:pt x="10913776" y="0"/>
                   </a:lnTo>
                   <a:lnTo>
-                    <a:pt x="10916428" y="0"/>
+                    <a:pt x="10913776" y="0"/>
                   </a:lnTo>
                 </a:path>
               </a:pathLst>
@@ -4117,21 +4117,21 @@
           </p:nvSpPr>
           <p:spPr>
             <a:xfrm>
-              <a:off x="797995" y="2626601"/>
-              <a:ext cx="10916428" cy="0"/>
+              <a:off x="800647" y="2625668"/>
+              <a:ext cx="10913776" cy="0"/>
             </a:xfrm>
             <a:custGeom>
               <a:avLst/>
               <a:pathLst>
-                <a:path w="10916428" h="0">
+                <a:path w="10913776" h="0">
                   <a:moveTo>
                     <a:pt x="0" y="0"/>
                   </a:moveTo>
                   <a:lnTo>
-                    <a:pt x="10916428" y="0"/>
+                    <a:pt x="10913776" y="0"/>
                   </a:lnTo>
                   <a:lnTo>
-                    <a:pt x="10916428" y="0"/>
+                    <a:pt x="10913776" y="0"/>
                   </a:lnTo>
                 </a:path>
               </a:pathLst>
@@ -4160,21 +4160,21 @@
           </p:nvSpPr>
           <p:spPr>
             <a:xfrm>
-              <a:off x="797995" y="1888818"/>
-              <a:ext cx="10916428" cy="0"/>
+              <a:off x="800647" y="1888804"/>
+              <a:ext cx="10913776" cy="0"/>
             </a:xfrm>
             <a:custGeom>
               <a:avLst/>
               <a:pathLst>
-                <a:path w="10916428" h="0">
+                <a:path w="10913776" h="0">
                   <a:moveTo>
                     <a:pt x="0" y="0"/>
                   </a:moveTo>
                   <a:lnTo>
-                    <a:pt x="10916428" y="0"/>
+                    <a:pt x="10913776" y="0"/>
                   </a:lnTo>
                   <a:lnTo>
-                    <a:pt x="10916428" y="0"/>
+                    <a:pt x="10913776" y="0"/>
                   </a:lnTo>
                 </a:path>
               </a:pathLst>
@@ -4203,15 +4203,15 @@
           </p:nvSpPr>
           <p:spPr>
             <a:xfrm>
-              <a:off x="2529942" y="1877752"/>
-              <a:ext cx="0" cy="3814338"/>
+              <a:off x="2532173" y="1877752"/>
+              <a:ext cx="0" cy="3809583"/>
             </a:xfrm>
             <a:custGeom>
               <a:avLst/>
               <a:pathLst>
-                <a:path w="0" h="3814338">
+                <a:path w="0" h="3809583">
                   <a:moveTo>
-                    <a:pt x="0" y="3814338"/>
+                    <a:pt x="0" y="3809583"/>
                   </a:moveTo>
                   <a:lnTo>
                     <a:pt x="0" y="0"/>
@@ -4246,15 +4246,15 @@
           </p:nvSpPr>
           <p:spPr>
             <a:xfrm>
-              <a:off x="5067407" y="1877752"/>
-              <a:ext cx="0" cy="3814338"/>
+              <a:off x="5069021" y="1877752"/>
+              <a:ext cx="0" cy="3809583"/>
             </a:xfrm>
             <a:custGeom>
               <a:avLst/>
               <a:pathLst>
-                <a:path w="0" h="3814338">
+                <a:path w="0" h="3809583">
                   <a:moveTo>
-                    <a:pt x="0" y="3814338"/>
+                    <a:pt x="0" y="3809583"/>
                   </a:moveTo>
                   <a:lnTo>
                     <a:pt x="0" y="0"/>
@@ -4289,15 +4289,15 @@
           </p:nvSpPr>
           <p:spPr>
             <a:xfrm>
-              <a:off x="7604872" y="1877752"/>
-              <a:ext cx="0" cy="3814338"/>
+              <a:off x="7605870" y="1877752"/>
+              <a:ext cx="0" cy="3809583"/>
             </a:xfrm>
             <a:custGeom>
               <a:avLst/>
               <a:pathLst>
-                <a:path w="0" h="3814338">
+                <a:path w="0" h="3809583">
                   <a:moveTo>
-                    <a:pt x="0" y="3814338"/>
+                    <a:pt x="0" y="3809583"/>
                   </a:moveTo>
                   <a:lnTo>
                     <a:pt x="0" y="0"/>
@@ -4332,15 +4332,15 @@
           </p:nvSpPr>
           <p:spPr>
             <a:xfrm>
-              <a:off x="10142337" y="1877752"/>
-              <a:ext cx="0" cy="3814338"/>
+              <a:off x="10142719" y="1877752"/>
+              <a:ext cx="0" cy="3809583"/>
             </a:xfrm>
             <a:custGeom>
               <a:avLst/>
               <a:pathLst>
-                <a:path w="0" h="3814338">
+                <a:path w="0" h="3809583">
                   <a:moveTo>
-                    <a:pt x="0" y="3814338"/>
+                    <a:pt x="0" y="3809583"/>
                   </a:moveTo>
                   <a:lnTo>
                     <a:pt x="0" y="0"/>
@@ -4375,7 +4375,7 @@
           </p:nvSpPr>
           <p:spPr>
             <a:xfrm>
-              <a:off x="4070095" y="3921536"/>
+              <a:off x="4071944" y="3918947"/>
               <a:ext cx="66150" cy="66150"/>
             </a:xfrm>
             <a:prstGeom prst="ellipse">
@@ -4410,7 +4410,7 @@
           </p:nvSpPr>
           <p:spPr>
             <a:xfrm>
-              <a:off x="4717149" y="3921536"/>
+              <a:off x="4718840" y="3918947"/>
               <a:ext cx="66150" cy="66150"/>
             </a:xfrm>
             <a:prstGeom prst="ellipse">
@@ -4445,7 +4445,7 @@
           </p:nvSpPr>
           <p:spPr>
             <a:xfrm>
-              <a:off x="3308856" y="3655934"/>
+              <a:off x="3310889" y="3653676"/>
               <a:ext cx="66150" cy="66150"/>
             </a:xfrm>
             <a:prstGeom prst="ellipse">
@@ -4480,7 +4480,7 @@
           </p:nvSpPr>
           <p:spPr>
             <a:xfrm>
-              <a:off x="5579887" y="3862513"/>
+              <a:off x="5581369" y="3859998"/>
               <a:ext cx="66150" cy="66150"/>
             </a:xfrm>
             <a:prstGeom prst="ellipse">
@@ -4515,7 +4515,7 @@
           </p:nvSpPr>
           <p:spPr>
             <a:xfrm>
-              <a:off x="6150816" y="4260916"/>
+              <a:off x="6152160" y="4257904"/>
               <a:ext cx="66150" cy="66150"/>
             </a:xfrm>
             <a:prstGeom prst="ellipse">
@@ -4550,7 +4550,7 @@
           </p:nvSpPr>
           <p:spPr>
             <a:xfrm>
-              <a:off x="6201566" y="4349450"/>
+              <a:off x="6202897" y="4346328"/>
               <a:ext cx="66150" cy="66150"/>
             </a:xfrm>
             <a:prstGeom prst="ellipse">
@@ -4585,7 +4585,7 @@
           </p:nvSpPr>
           <p:spPr>
             <a:xfrm>
-              <a:off x="6480687" y="4910165"/>
+              <a:off x="6481950" y="4906344"/>
               <a:ext cx="66150" cy="66150"/>
             </a:xfrm>
             <a:prstGeom prst="ellipse">
@@ -4620,7 +4620,7 @@
           </p:nvSpPr>
           <p:spPr>
             <a:xfrm>
-              <a:off x="5516450" y="3419843"/>
+              <a:off x="5517948" y="3417880"/>
               <a:ext cx="66150" cy="66150"/>
             </a:xfrm>
             <a:prstGeom prst="ellipse">
@@ -4655,7 +4655,7 @@
           </p:nvSpPr>
           <p:spPr>
             <a:xfrm>
-              <a:off x="5414952" y="3655934"/>
+              <a:off x="5416474" y="3653676"/>
               <a:ext cx="66150" cy="66150"/>
             </a:xfrm>
             <a:prstGeom prst="ellipse">
@@ -4690,7 +4690,7 @@
           </p:nvSpPr>
           <p:spPr>
             <a:xfrm>
-              <a:off x="6150816" y="4187138"/>
+              <a:off x="6152160" y="4184218"/>
               <a:ext cx="66150" cy="66150"/>
             </a:xfrm>
             <a:prstGeom prst="ellipse">
@@ -4725,7 +4725,7 @@
           </p:nvSpPr>
           <p:spPr>
             <a:xfrm>
-              <a:off x="6150816" y="4393717"/>
+              <a:off x="6152160" y="4390540"/>
               <a:ext cx="66150" cy="66150"/>
             </a:xfrm>
             <a:prstGeom prst="ellipse">
@@ -4760,7 +4760,7 @@
           </p:nvSpPr>
           <p:spPr>
             <a:xfrm>
-              <a:off x="7749419" y="4600296"/>
+              <a:off x="7750375" y="4596861"/>
               <a:ext cx="66150" cy="66150"/>
             </a:xfrm>
             <a:prstGeom prst="ellipse">
@@ -4795,7 +4795,7 @@
           </p:nvSpPr>
           <p:spPr>
             <a:xfrm>
-              <a:off x="6886681" y="4467495"/>
+              <a:off x="6887846" y="4464226"/>
               <a:ext cx="66150" cy="66150"/>
             </a:xfrm>
             <a:prstGeom prst="ellipse">
@@ -4830,7 +4830,7 @@
           </p:nvSpPr>
           <p:spPr>
             <a:xfrm>
-              <a:off x="7013555" y="4777364"/>
+              <a:off x="7014688" y="4773709"/>
               <a:ext cx="66150" cy="66150"/>
             </a:xfrm>
             <a:prstGeom prst="ellipse">
@@ -4865,7 +4865,7 @@
           </p:nvSpPr>
           <p:spPr>
             <a:xfrm>
-              <a:off x="10743628" y="5485636"/>
+              <a:off x="10743856" y="5481097"/>
               <a:ext cx="66150" cy="66150"/>
             </a:xfrm>
             <a:prstGeom prst="ellipse">
@@ -4900,7 +4900,7 @@
           </p:nvSpPr>
           <p:spPr>
             <a:xfrm>
-              <a:off x="11185147" y="5485636"/>
+              <a:off x="11185268" y="5481097"/>
               <a:ext cx="66150" cy="66150"/>
             </a:xfrm>
             <a:prstGeom prst="ellipse">
@@ -4935,7 +4935,7 @@
           </p:nvSpPr>
           <p:spPr>
             <a:xfrm>
-              <a:off x="10984687" y="4851143"/>
+              <a:off x="10984857" y="4847395"/>
               <a:ext cx="66150" cy="66150"/>
             </a:xfrm>
             <a:prstGeom prst="ellipse">
@@ -4970,7 +4970,7 @@
           </p:nvSpPr>
           <p:spPr>
             <a:xfrm>
-              <a:off x="3004360" y="2239390"/>
+              <a:off x="3006467" y="2238898"/>
               <a:ext cx="66150" cy="66150"/>
             </a:xfrm>
             <a:prstGeom prst="ellipse">
@@ -5005,7 +5005,7 @@
           </p:nvSpPr>
           <p:spPr>
             <a:xfrm>
-              <a:off x="1519943" y="2534504"/>
+              <a:off x="1522411" y="2533644"/>
               <a:ext cx="66150" cy="66150"/>
             </a:xfrm>
             <a:prstGeom prst="ellipse">
@@ -5040,7 +5040,7 @@
           </p:nvSpPr>
           <p:spPr>
             <a:xfrm>
-              <a:off x="2078185" y="2018056"/>
+              <a:off x="2080518" y="2017839"/>
               <a:ext cx="66150" cy="66150"/>
             </a:xfrm>
             <a:prstGeom prst="ellipse">
@@ -5075,7 +5075,7 @@
           </p:nvSpPr>
           <p:spPr>
             <a:xfrm>
-              <a:off x="3676788" y="3847758"/>
+              <a:off x="3678732" y="3845261"/>
               <a:ext cx="66150" cy="66150"/>
             </a:xfrm>
             <a:prstGeom prst="ellipse">
@@ -5110,7 +5110,7 @@
           </p:nvSpPr>
           <p:spPr>
             <a:xfrm>
-              <a:off x="6353814" y="4733097"/>
+              <a:off x="6355108" y="4729497"/>
               <a:ext cx="66150" cy="66150"/>
             </a:xfrm>
             <a:prstGeom prst="ellipse">
@@ -5145,7 +5145,7 @@
           </p:nvSpPr>
           <p:spPr>
             <a:xfrm>
-              <a:off x="6138129" y="4777364"/>
+              <a:off x="6139476" y="4773709"/>
               <a:ext cx="66150" cy="66150"/>
             </a:xfrm>
             <a:prstGeom prst="ellipse">
@@ -5180,7 +5180,7 @@
           </p:nvSpPr>
           <p:spPr>
             <a:xfrm>
-              <a:off x="7165802" y="5057722"/>
+              <a:off x="7166899" y="5053717"/>
               <a:ext cx="66150" cy="66150"/>
             </a:xfrm>
             <a:prstGeom prst="ellipse">
@@ -5215,7 +5215,7 @@
           </p:nvSpPr>
           <p:spPr>
             <a:xfrm>
-              <a:off x="7178490" y="4187138"/>
+              <a:off x="7179584" y="4184218"/>
               <a:ext cx="66150" cy="66150"/>
             </a:xfrm>
             <a:prstGeom prst="ellipse">
@@ -5250,7 +5250,7 @@
           </p:nvSpPr>
           <p:spPr>
             <a:xfrm>
-              <a:off x="2331931" y="2991929"/>
+              <a:off x="2334203" y="2990499"/>
               <a:ext cx="66150" cy="66150"/>
             </a:xfrm>
             <a:prstGeom prst="ellipse">
@@ -5285,7 +5285,7 @@
           </p:nvSpPr>
           <p:spPr>
             <a:xfrm>
-              <a:off x="2852112" y="3183753"/>
+              <a:off x="2854257" y="3182084"/>
               <a:ext cx="66150" cy="66150"/>
             </a:xfrm>
             <a:prstGeom prst="ellipse">
@@ -5320,7 +5320,7 @@
           </p:nvSpPr>
           <p:spPr>
             <a:xfrm>
-              <a:off x="1261121" y="2534504"/>
+              <a:off x="1263652" y="2533644"/>
               <a:ext cx="66150" cy="66150"/>
             </a:xfrm>
             <a:prstGeom prst="ellipse">
@@ -5355,7 +5355,7 @@
           </p:nvSpPr>
           <p:spPr>
             <a:xfrm>
-              <a:off x="5465701" y="4688830"/>
+              <a:off x="5467211" y="4685285"/>
               <a:ext cx="66150" cy="66150"/>
             </a:xfrm>
             <a:prstGeom prst="ellipse">
@@ -5390,7 +5390,7 @@
           </p:nvSpPr>
           <p:spPr>
             <a:xfrm>
-              <a:off x="4450715" y="4113360"/>
+              <a:off x="4452471" y="4110531"/>
               <a:ext cx="66150" cy="66150"/>
             </a:xfrm>
             <a:prstGeom prst="ellipse">
@@ -5425,7 +5425,7 @@
           </p:nvSpPr>
           <p:spPr>
             <a:xfrm>
-              <a:off x="6480687" y="4806876"/>
+              <a:off x="6481950" y="4803183"/>
               <a:ext cx="66150" cy="66150"/>
             </a:xfrm>
             <a:prstGeom prst="ellipse">
@@ -5460,7 +5460,7 @@
           </p:nvSpPr>
           <p:spPr>
             <a:xfrm>
-              <a:off x="4476089" y="3862513"/>
+              <a:off x="4477840" y="3859998"/>
               <a:ext cx="66150" cy="66150"/>
             </a:xfrm>
             <a:prstGeom prst="ellipse">
@@ -5495,7 +5495,7 @@
           </p:nvSpPr>
           <p:spPr>
             <a:xfrm>
-              <a:off x="605703" y="5538186"/>
+              <a:off x="608355" y="5533574"/>
               <a:ext cx="129661" cy="79095"/>
             </a:xfrm>
             <a:prstGeom prst="rect">
@@ -5541,7 +5541,7 @@
           </p:nvSpPr>
           <p:spPr>
             <a:xfrm>
-              <a:off x="605703" y="4800403"/>
+              <a:off x="608355" y="4796710"/>
               <a:ext cx="129661" cy="79095"/>
             </a:xfrm>
             <a:prstGeom prst="rect">
@@ -5587,7 +5587,7 @@
           </p:nvSpPr>
           <p:spPr>
             <a:xfrm>
-              <a:off x="605703" y="4062620"/>
+              <a:off x="608355" y="4059847"/>
               <a:ext cx="129661" cy="79095"/>
             </a:xfrm>
             <a:prstGeom prst="rect">
@@ -5633,7 +5633,7 @@
           </p:nvSpPr>
           <p:spPr>
             <a:xfrm>
-              <a:off x="605703" y="3324837"/>
+              <a:off x="608355" y="3322983"/>
               <a:ext cx="129661" cy="79095"/>
             </a:xfrm>
             <a:prstGeom prst="rect">
@@ -5679,7 +5679,7 @@
           </p:nvSpPr>
           <p:spPr>
             <a:xfrm>
-              <a:off x="605703" y="2587054"/>
+              <a:off x="608355" y="2586120"/>
               <a:ext cx="129661" cy="79095"/>
             </a:xfrm>
             <a:prstGeom prst="rect">
@@ -5725,7 +5725,7 @@
           </p:nvSpPr>
           <p:spPr>
             <a:xfrm>
-              <a:off x="605703" y="1849270"/>
+              <a:off x="608355" y="1849257"/>
               <a:ext cx="129661" cy="79095"/>
             </a:xfrm>
             <a:prstGeom prst="rect">
@@ -5771,7 +5771,7 @@
           </p:nvSpPr>
           <p:spPr>
             <a:xfrm>
-              <a:off x="763200" y="5577734"/>
+              <a:off x="765852" y="5573121"/>
               <a:ext cx="34794" cy="0"/>
             </a:xfrm>
             <a:custGeom>
@@ -5811,7 +5811,7 @@
           </p:nvSpPr>
           <p:spPr>
             <a:xfrm>
-              <a:off x="763200" y="4839951"/>
+              <a:off x="765852" y="4836258"/>
               <a:ext cx="34794" cy="0"/>
             </a:xfrm>
             <a:custGeom>
@@ -5851,7 +5851,7 @@
           </p:nvSpPr>
           <p:spPr>
             <a:xfrm>
-              <a:off x="763200" y="4102168"/>
+              <a:off x="765852" y="4099395"/>
               <a:ext cx="34794" cy="0"/>
             </a:xfrm>
             <a:custGeom>
@@ -5891,7 +5891,7 @@
           </p:nvSpPr>
           <p:spPr>
             <a:xfrm>
-              <a:off x="763200" y="3364384"/>
+              <a:off x="765852" y="3362531"/>
               <a:ext cx="34794" cy="0"/>
             </a:xfrm>
             <a:custGeom>
@@ -5931,7 +5931,7 @@
           </p:nvSpPr>
           <p:spPr>
             <a:xfrm>
-              <a:off x="763200" y="2626601"/>
+              <a:off x="765852" y="2625668"/>
               <a:ext cx="34794" cy="0"/>
             </a:xfrm>
             <a:custGeom>
@@ -5971,7 +5971,7 @@
           </p:nvSpPr>
           <p:spPr>
             <a:xfrm>
-              <a:off x="763200" y="1888818"/>
+              <a:off x="765852" y="1888804"/>
               <a:ext cx="34794" cy="0"/>
             </a:xfrm>
             <a:custGeom>
@@ -6011,7 +6011,7 @@
           </p:nvSpPr>
           <p:spPr>
             <a:xfrm>
-              <a:off x="2529942" y="5692090"/>
+              <a:off x="2532173" y="5687335"/>
               <a:ext cx="0" cy="34794"/>
             </a:xfrm>
             <a:custGeom>
@@ -6051,7 +6051,7 @@
           </p:nvSpPr>
           <p:spPr>
             <a:xfrm>
-              <a:off x="5067407" y="5692090"/>
+              <a:off x="5069021" y="5687335"/>
               <a:ext cx="0" cy="34794"/>
             </a:xfrm>
             <a:custGeom>
@@ -6091,7 +6091,7 @@
           </p:nvSpPr>
           <p:spPr>
             <a:xfrm>
-              <a:off x="7604872" y="5692090"/>
+              <a:off x="7605870" y="5687335"/>
               <a:ext cx="0" cy="34794"/>
             </a:xfrm>
             <a:custGeom>
@@ -6131,7 +6131,7 @@
           </p:nvSpPr>
           <p:spPr>
             <a:xfrm>
-              <a:off x="10142337" y="5692090"/>
+              <a:off x="10142719" y="5687335"/>
               <a:ext cx="0" cy="34794"/>
             </a:xfrm>
             <a:custGeom>
@@ -6171,7 +6171,7 @@
           </p:nvSpPr>
           <p:spPr>
             <a:xfrm>
-              <a:off x="2497526" y="5754720"/>
+              <a:off x="2499757" y="5749965"/>
               <a:ext cx="64830" cy="79095"/>
             </a:xfrm>
             <a:prstGeom prst="rect">
@@ -6217,7 +6217,7 @@
           </p:nvSpPr>
           <p:spPr>
             <a:xfrm>
-              <a:off x="5034991" y="5754720"/>
+              <a:off x="5036606" y="5749965"/>
               <a:ext cx="64830" cy="79095"/>
             </a:xfrm>
             <a:prstGeom prst="rect">
@@ -6263,7 +6263,7 @@
           </p:nvSpPr>
           <p:spPr>
             <a:xfrm>
-              <a:off x="7572456" y="5754720"/>
+              <a:off x="7573455" y="5749965"/>
               <a:ext cx="64830" cy="79095"/>
             </a:xfrm>
             <a:prstGeom prst="rect">
@@ -6309,7 +6309,7 @@
           </p:nvSpPr>
           <p:spPr>
             <a:xfrm>
-              <a:off x="10109921" y="5754720"/>
+              <a:off x="10110303" y="5749965"/>
               <a:ext cx="64830" cy="79095"/>
             </a:xfrm>
             <a:prstGeom prst="rect">
@@ -6355,7 +6355,7 @@
           </p:nvSpPr>
           <p:spPr>
             <a:xfrm>
-              <a:off x="6181960" y="5893391"/>
+              <a:off x="6183286" y="5890739"/>
               <a:ext cx="148498" cy="98938"/>
             </a:xfrm>
             <a:prstGeom prst="rect">
@@ -6401,7 +6401,7 @@
           </p:nvSpPr>
           <p:spPr>
             <a:xfrm rot="-5400000">
-              <a:off x="340342" y="3735452"/>
+              <a:off x="340342" y="3733074"/>
               <a:ext cx="300380" cy="98938"/>
             </a:xfrm>
             <a:prstGeom prst="rect">
@@ -6596,7 +6596,7 @@
           <p:spPr>
             <a:xfrm>
               <a:off x="581807" y="1899602"/>
-              <a:ext cx="11092477" cy="3560315"/>
+              <a:ext cx="11092477" cy="3551720"/>
             </a:xfrm>
             <a:prstGeom prst="rect">
               <a:avLst/>
@@ -6621,7 +6621,7 @@
           </p:nvSpPr>
           <p:spPr>
             <a:xfrm>
-              <a:off x="581807" y="4895056"/>
+              <a:off x="581807" y="4887824"/>
               <a:ext cx="11092477" cy="0"/>
             </a:xfrm>
             <a:custGeom>
@@ -6664,7 +6664,7 @@
           </p:nvSpPr>
           <p:spPr>
             <a:xfrm>
-              <a:off x="581807" y="4067480"/>
+              <a:off x="581807" y="4062246"/>
               <a:ext cx="11092477" cy="0"/>
             </a:xfrm>
             <a:custGeom>
@@ -6707,7 +6707,7 @@
           </p:nvSpPr>
           <p:spPr>
             <a:xfrm>
-              <a:off x="581807" y="3239903"/>
+              <a:off x="581807" y="3236668"/>
               <a:ext cx="11092477" cy="0"/>
             </a:xfrm>
             <a:custGeom>
@@ -6750,7 +6750,7 @@
           </p:nvSpPr>
           <p:spPr>
             <a:xfrm>
-              <a:off x="581807" y="2412327"/>
+              <a:off x="581807" y="2411089"/>
               <a:ext cx="11092477" cy="0"/>
             </a:xfrm>
             <a:custGeom>
@@ -6793,7 +6793,7 @@
           </p:nvSpPr>
           <p:spPr>
             <a:xfrm>
-              <a:off x="5601495" y="4348884"/>
+              <a:off x="5601495" y="4342891"/>
               <a:ext cx="66150" cy="66150"/>
             </a:xfrm>
             <a:prstGeom prst="ellipse">
@@ -6828,7 +6828,7 @@
           </p:nvSpPr>
           <p:spPr>
             <a:xfrm>
-              <a:off x="5601495" y="4137852"/>
+              <a:off x="5601495" y="4132368"/>
               <a:ext cx="66150" cy="66150"/>
             </a:xfrm>
             <a:prstGeom prst="ellipse">
@@ -6863,7 +6863,7 @@
           </p:nvSpPr>
           <p:spPr>
             <a:xfrm>
-              <a:off x="6373892" y="4597156"/>
+              <a:off x="6373892" y="4590564"/>
               <a:ext cx="66150" cy="66150"/>
             </a:xfrm>
             <a:prstGeom prst="ellipse">
@@ -6898,7 +6898,7 @@
           </p:nvSpPr>
           <p:spPr>
             <a:xfrm>
-              <a:off x="5773139" y="3856476"/>
+              <a:off x="5773139" y="3851672"/>
               <a:ext cx="66150" cy="66150"/>
             </a:xfrm>
             <a:prstGeom prst="ellipse">
@@ -6933,7 +6933,7 @@
           </p:nvSpPr>
           <p:spPr>
             <a:xfrm>
-              <a:off x="4614543" y="3670271"/>
+              <a:off x="4614543" y="3665917"/>
               <a:ext cx="66150" cy="66150"/>
             </a:xfrm>
             <a:prstGeom prst="ellipse">
@@ -6968,7 +6968,7 @@
           </p:nvSpPr>
           <p:spPr>
             <a:xfrm>
-              <a:off x="4357078" y="3653720"/>
+              <a:off x="4357078" y="3649405"/>
               <a:ext cx="66150" cy="66150"/>
             </a:xfrm>
             <a:prstGeom prst="ellipse">
@@ -7003,7 +7003,7 @@
           </p:nvSpPr>
           <p:spPr>
             <a:xfrm>
-              <a:off x="2726462" y="3562686"/>
+              <a:off x="2726462" y="3558591"/>
               <a:ext cx="66150" cy="66150"/>
             </a:xfrm>
             <a:prstGeom prst="ellipse">
@@ -7038,7 +7038,7 @@
           </p:nvSpPr>
           <p:spPr>
             <a:xfrm>
-              <a:off x="7060467" y="3877165"/>
+              <a:off x="7060467" y="3872311"/>
               <a:ext cx="66150" cy="66150"/>
             </a:xfrm>
             <a:prstGeom prst="ellipse">
@@ -7073,7 +7073,7 @@
           </p:nvSpPr>
           <p:spPr>
             <a:xfrm>
-              <a:off x="6373892" y="3910268"/>
+              <a:off x="6373892" y="3905334"/>
               <a:ext cx="66150" cy="66150"/>
             </a:xfrm>
             <a:prstGeom prst="ellipse">
@@ -7108,7 +7108,7 @@
           </p:nvSpPr>
           <p:spPr>
             <a:xfrm>
-              <a:off x="4829098" y="3670271"/>
+              <a:off x="4829098" y="3665917"/>
               <a:ext cx="66150" cy="66150"/>
             </a:xfrm>
             <a:prstGeom prst="ellipse">
@@ -7143,7 +7143,7 @@
           </p:nvSpPr>
           <p:spPr>
             <a:xfrm>
-              <a:off x="4228345" y="3670271"/>
+              <a:off x="4228345" y="3665917"/>
               <a:ext cx="66150" cy="66150"/>
             </a:xfrm>
             <a:prstGeom prst="ellipse">
@@ -7178,7 +7178,7 @@
           </p:nvSpPr>
           <p:spPr>
             <a:xfrm>
-              <a:off x="3627592" y="3148898"/>
+              <a:off x="3627592" y="3145802"/>
               <a:ext cx="66150" cy="66150"/>
             </a:xfrm>
             <a:prstGeom prst="ellipse">
@@ -7213,7 +7213,7 @@
           </p:nvSpPr>
           <p:spPr>
             <a:xfrm>
-              <a:off x="4013790" y="3430274"/>
+              <a:off x="4013790" y="3426499"/>
               <a:ext cx="66150" cy="66150"/>
             </a:xfrm>
             <a:prstGeom prst="ellipse">
@@ -7248,7 +7248,7 @@
           </p:nvSpPr>
           <p:spPr>
             <a:xfrm>
-              <a:off x="3112660" y="3388895"/>
+              <a:off x="3112660" y="3385220"/>
               <a:ext cx="66150" cy="66150"/>
             </a:xfrm>
             <a:prstGeom prst="ellipse">
@@ -7283,7 +7283,7 @@
           </p:nvSpPr>
           <p:spPr>
             <a:xfrm>
-              <a:off x="1052935" y="2172358"/>
+              <a:off x="1052935" y="2171620"/>
               <a:ext cx="66150" cy="66150"/>
             </a:xfrm>
             <a:prstGeom prst="ellipse">
@@ -7318,7 +7318,7 @@
           </p:nvSpPr>
           <p:spPr>
             <a:xfrm>
-              <a:off x="1052935" y="2028360"/>
+              <a:off x="1052935" y="2027969"/>
               <a:ext cx="66150" cy="66150"/>
             </a:xfrm>
             <a:prstGeom prst="ellipse">
@@ -7353,7 +7353,7 @@
           </p:nvSpPr>
           <p:spPr>
             <a:xfrm>
-              <a:off x="2898106" y="2093739"/>
+              <a:off x="2898106" y="2093190"/>
               <a:ext cx="66150" cy="66150"/>
             </a:xfrm>
             <a:prstGeom prst="ellipse">
@@ -7388,7 +7388,7 @@
           </p:nvSpPr>
           <p:spPr>
             <a:xfrm>
-              <a:off x="10493342" y="4696466"/>
+              <a:off x="10493342" y="4689634"/>
               <a:ext cx="66150" cy="66150"/>
             </a:xfrm>
             <a:prstGeom prst="ellipse">
@@ -7423,7 +7423,7 @@
           </p:nvSpPr>
           <p:spPr>
             <a:xfrm>
-              <a:off x="9635123" y="5180598"/>
+              <a:off x="9635123" y="5172597"/>
               <a:ext cx="66150" cy="66150"/>
             </a:xfrm>
             <a:prstGeom prst="ellipse">
@@ -7458,7 +7458,7 @@
           </p:nvSpPr>
           <p:spPr>
             <a:xfrm>
-              <a:off x="11137006" y="4998531"/>
+              <a:off x="11137006" y="4990970"/>
               <a:ext cx="66150" cy="66150"/>
             </a:xfrm>
             <a:prstGeom prst="ellipse">
@@ -7493,7 +7493,7 @@
           </p:nvSpPr>
           <p:spPr>
             <a:xfrm>
-              <a:off x="5816049" y="4477158"/>
+              <a:off x="5816049" y="4470855"/>
               <a:ext cx="66150" cy="66150"/>
             </a:xfrm>
             <a:prstGeom prst="ellipse">
@@ -7528,7 +7528,7 @@
           </p:nvSpPr>
           <p:spPr>
             <a:xfrm>
-              <a:off x="3241393" y="3604065"/>
+              <a:off x="3241393" y="3599870"/>
               <a:ext cx="66150" cy="66150"/>
             </a:xfrm>
             <a:prstGeom prst="ellipse">
@@ -7563,7 +7563,7 @@
           </p:nvSpPr>
           <p:spPr>
             <a:xfrm>
-              <a:off x="3112660" y="3674409"/>
+              <a:off x="3112660" y="3670044"/>
               <a:ext cx="66150" cy="66150"/>
             </a:xfrm>
             <a:prstGeom prst="ellipse">
@@ -7598,7 +7598,7 @@
           </p:nvSpPr>
           <p:spPr>
             <a:xfrm>
-              <a:off x="2297352" y="3339241"/>
+              <a:off x="2297352" y="3335685"/>
               <a:ext cx="66150" cy="66150"/>
             </a:xfrm>
             <a:prstGeom prst="ellipse">
@@ -7633,7 +7633,7 @@
           </p:nvSpPr>
           <p:spPr>
             <a:xfrm>
-              <a:off x="4829098" y="3335103"/>
+              <a:off x="4829098" y="3331557"/>
               <a:ext cx="66150" cy="66150"/>
             </a:xfrm>
             <a:prstGeom prst="ellipse">
@@ -7668,7 +7668,7 @@
           </p:nvSpPr>
           <p:spPr>
             <a:xfrm>
-              <a:off x="8304884" y="4915773"/>
+              <a:off x="8304884" y="4908412"/>
               <a:ext cx="66150" cy="66150"/>
             </a:xfrm>
             <a:prstGeom prst="ellipse">
@@ -7703,7 +7703,7 @@
           </p:nvSpPr>
           <p:spPr>
             <a:xfrm>
-              <a:off x="7747042" y="4746120"/>
+              <a:off x="7747042" y="4739168"/>
               <a:ext cx="66150" cy="66150"/>
             </a:xfrm>
             <a:prstGeom prst="ellipse">
@@ -7738,7 +7738,7 @@
           </p:nvSpPr>
           <p:spPr>
             <a:xfrm>
-              <a:off x="9635123" y="5265010"/>
+              <a:off x="9635123" y="5256806"/>
               <a:ext cx="66150" cy="66150"/>
             </a:xfrm>
             <a:prstGeom prst="ellipse">
@@ -7773,7 +7773,7 @@
           </p:nvSpPr>
           <p:spPr>
             <a:xfrm>
-              <a:off x="3370126" y="3893717"/>
+              <a:off x="3370126" y="3888823"/>
               <a:ext cx="66150" cy="66150"/>
             </a:xfrm>
             <a:prstGeom prst="ellipse">
@@ -7808,7 +7808,7 @@
           </p:nvSpPr>
           <p:spPr>
             <a:xfrm>
-              <a:off x="5043653" y="4224747"/>
+              <a:off x="5043653" y="4219054"/>
               <a:ext cx="66150" cy="66150"/>
             </a:xfrm>
             <a:prstGeom prst="ellipse">
@@ -7843,7 +7843,7 @@
           </p:nvSpPr>
           <p:spPr>
             <a:xfrm>
-              <a:off x="3026838" y="3562686"/>
+              <a:off x="3026838" y="3558591"/>
               <a:ext cx="66150" cy="66150"/>
             </a:xfrm>
             <a:prstGeom prst="ellipse">
@@ -7878,7 +7878,7 @@
           </p:nvSpPr>
           <p:spPr>
             <a:xfrm>
-              <a:off x="5773139" y="4216471"/>
+              <a:off x="5773139" y="4210798"/>
               <a:ext cx="66150" cy="66150"/>
             </a:xfrm>
             <a:prstGeom prst="ellipse">
@@ -7913,7 +7913,7 @@
           </p:nvSpPr>
           <p:spPr>
             <a:xfrm>
-              <a:off x="373303" y="4814131"/>
+              <a:off x="373303" y="4806900"/>
               <a:ext cx="132588" cy="161848"/>
             </a:xfrm>
             <a:prstGeom prst="rect">
@@ -7959,7 +7959,7 @@
           </p:nvSpPr>
           <p:spPr>
             <a:xfrm>
-              <a:off x="373303" y="3986555"/>
+              <a:off x="373303" y="3981322"/>
               <a:ext cx="132588" cy="161848"/>
             </a:xfrm>
             <a:prstGeom prst="rect">
@@ -8005,7 +8005,7 @@
           </p:nvSpPr>
           <p:spPr>
             <a:xfrm>
-              <a:off x="373303" y="3158979"/>
+              <a:off x="373303" y="3155743"/>
               <a:ext cx="132588" cy="161848"/>
             </a:xfrm>
             <a:prstGeom prst="rect">
@@ -8051,7 +8051,7 @@
           </p:nvSpPr>
           <p:spPr>
             <a:xfrm>
-              <a:off x="373303" y="2331403"/>
+              <a:off x="373303" y="2330165"/>
               <a:ext cx="132588" cy="161848"/>
             </a:xfrm>
             <a:prstGeom prst="rect">
@@ -8097,7 +8097,7 @@
           </p:nvSpPr>
           <p:spPr>
             <a:xfrm>
-              <a:off x="581807" y="5459918"/>
+              <a:off x="581807" y="5451323"/>
               <a:ext cx="11092477" cy="0"/>
             </a:xfrm>
             <a:custGeom>
@@ -8137,7 +8137,7 @@
           </p:nvSpPr>
           <p:spPr>
             <a:xfrm>
-              <a:off x="914366" y="5459918"/>
+              <a:off x="914366" y="5451323"/>
               <a:ext cx="0" cy="56936"/>
             </a:xfrm>
             <a:custGeom>
@@ -8177,7 +8177,7 @@
           </p:nvSpPr>
           <p:spPr>
             <a:xfrm>
-              <a:off x="3059913" y="5459918"/>
+              <a:off x="3059913" y="5451323"/>
               <a:ext cx="0" cy="56936"/>
             </a:xfrm>
             <a:custGeom>
@@ -8217,7 +8217,7 @@
           </p:nvSpPr>
           <p:spPr>
             <a:xfrm>
-              <a:off x="5205460" y="5459918"/>
+              <a:off x="5205460" y="5451323"/>
               <a:ext cx="0" cy="56936"/>
             </a:xfrm>
             <a:custGeom>
@@ -8257,7 +8257,7 @@
           </p:nvSpPr>
           <p:spPr>
             <a:xfrm>
-              <a:off x="7351007" y="5459918"/>
+              <a:off x="7351007" y="5451323"/>
               <a:ext cx="0" cy="56936"/>
             </a:xfrm>
             <a:custGeom>
@@ -8297,7 +8297,7 @@
           </p:nvSpPr>
           <p:spPr>
             <a:xfrm>
-              <a:off x="9496554" y="5459918"/>
+              <a:off x="9496554" y="5451323"/>
               <a:ext cx="0" cy="56936"/>
             </a:xfrm>
             <a:custGeom>
@@ -8337,7 +8337,7 @@
           </p:nvSpPr>
           <p:spPr>
             <a:xfrm>
-              <a:off x="11642101" y="5459918"/>
+              <a:off x="11642101" y="5451323"/>
               <a:ext cx="0" cy="56936"/>
             </a:xfrm>
             <a:custGeom>
@@ -8377,7 +8377,7 @@
           </p:nvSpPr>
           <p:spPr>
             <a:xfrm>
-              <a:off x="781778" y="5592770"/>
+              <a:off x="781778" y="5584174"/>
               <a:ext cx="265176" cy="161848"/>
             </a:xfrm>
             <a:prstGeom prst="rect">
@@ -8423,7 +8423,7 @@
           </p:nvSpPr>
           <p:spPr>
             <a:xfrm>
-              <a:off x="2927325" y="5592770"/>
+              <a:off x="2927325" y="5584174"/>
               <a:ext cx="265176" cy="161848"/>
             </a:xfrm>
             <a:prstGeom prst="rect">
@@ -8469,7 +8469,7 @@
           </p:nvSpPr>
           <p:spPr>
             <a:xfrm>
-              <a:off x="5072872" y="5592770"/>
+              <a:off x="5072872" y="5584174"/>
               <a:ext cx="265176" cy="161848"/>
             </a:xfrm>
             <a:prstGeom prst="rect">
@@ -8515,7 +8515,7 @@
           </p:nvSpPr>
           <p:spPr>
             <a:xfrm>
-              <a:off x="7218419" y="5592770"/>
+              <a:off x="7218419" y="5584174"/>
               <a:ext cx="265176" cy="161848"/>
             </a:xfrm>
             <a:prstGeom prst="rect">
@@ -8561,7 +8561,7 @@
           </p:nvSpPr>
           <p:spPr>
             <a:xfrm>
-              <a:off x="9363966" y="5592770"/>
+              <a:off x="9363966" y="5584174"/>
               <a:ext cx="265176" cy="161848"/>
             </a:xfrm>
             <a:prstGeom prst="rect">
@@ -8607,7 +8607,7 @@
           </p:nvSpPr>
           <p:spPr>
             <a:xfrm>
-              <a:off x="11509513" y="5592770"/>
+              <a:off x="11509513" y="5584174"/>
               <a:ext cx="265176" cy="161848"/>
             </a:xfrm>
             <a:prstGeom prst="rect">
@@ -8653,7 +8653,7 @@
           </p:nvSpPr>
           <p:spPr>
             <a:xfrm>
-              <a:off x="5882255" y="5862121"/>
+              <a:off x="5882255" y="5857824"/>
               <a:ext cx="491581" cy="161848"/>
             </a:xfrm>
             <a:prstGeom prst="rect">

</xml_diff>

<commit_message>
Improve font handling for charts
Previously, fonts for powerpoint and slide exports did not match grattan style guide. This update allows for correct fonts to be registered upon package loading, and then used upon chart export.
</commit_message>
<xml_diff>
--- a/tests/testthat/multi_slide_fullslide.pptx
+++ b/tests/testthat/multi_slide_fullslide.pptx
@@ -3489,8 +3489,8 @@
           </p:nvSpPr>
           <p:spPr>
             <a:xfrm>
-              <a:off x="800647" y="1877752"/>
-              <a:ext cx="10913776" cy="3809583"/>
+              <a:off x="797995" y="1877752"/>
+              <a:ext cx="10916428" cy="3814338"/>
             </a:xfrm>
             <a:prstGeom prst="rect">
               <a:avLst/>
@@ -3515,21 +3515,21 @@
           </p:nvSpPr>
           <p:spPr>
             <a:xfrm>
-              <a:off x="800647" y="5204690"/>
-              <a:ext cx="10913776" cy="0"/>
+              <a:off x="797995" y="5208842"/>
+              <a:ext cx="10916428" cy="0"/>
             </a:xfrm>
             <a:custGeom>
               <a:avLst/>
               <a:pathLst>
-                <a:path w="10913776" h="0">
+                <a:path w="10916428" h="0">
                   <a:moveTo>
                     <a:pt x="0" y="0"/>
                   </a:moveTo>
                   <a:lnTo>
-                    <a:pt x="10913776" y="0"/>
+                    <a:pt x="10916428" y="0"/>
                   </a:lnTo>
                   <a:lnTo>
-                    <a:pt x="10913776" y="0"/>
+                    <a:pt x="10916428" y="0"/>
                   </a:lnTo>
                 </a:path>
               </a:pathLst>
@@ -3558,21 +3558,21 @@
           </p:nvSpPr>
           <p:spPr>
             <a:xfrm>
-              <a:off x="800647" y="4467826"/>
-              <a:ext cx="10913776" cy="0"/>
+              <a:off x="797995" y="4471059"/>
+              <a:ext cx="10916428" cy="0"/>
             </a:xfrm>
             <a:custGeom>
               <a:avLst/>
               <a:pathLst>
-                <a:path w="10913776" h="0">
+                <a:path w="10916428" h="0">
                   <a:moveTo>
                     <a:pt x="0" y="0"/>
                   </a:moveTo>
                   <a:lnTo>
-                    <a:pt x="10913776" y="0"/>
+                    <a:pt x="10916428" y="0"/>
                   </a:lnTo>
                   <a:lnTo>
-                    <a:pt x="10913776" y="0"/>
+                    <a:pt x="10916428" y="0"/>
                   </a:lnTo>
                 </a:path>
               </a:pathLst>
@@ -3601,21 +3601,21 @@
           </p:nvSpPr>
           <p:spPr>
             <a:xfrm>
-              <a:off x="800647" y="3730963"/>
-              <a:ext cx="10913776" cy="0"/>
+              <a:off x="797995" y="3733276"/>
+              <a:ext cx="10916428" cy="0"/>
             </a:xfrm>
             <a:custGeom>
               <a:avLst/>
               <a:pathLst>
-                <a:path w="10913776" h="0">
+                <a:path w="10916428" h="0">
                   <a:moveTo>
                     <a:pt x="0" y="0"/>
                   </a:moveTo>
                   <a:lnTo>
-                    <a:pt x="10913776" y="0"/>
+                    <a:pt x="10916428" y="0"/>
                   </a:lnTo>
                   <a:lnTo>
-                    <a:pt x="10913776" y="0"/>
+                    <a:pt x="10916428" y="0"/>
                   </a:lnTo>
                 </a:path>
               </a:pathLst>
@@ -3644,21 +3644,21 @@
           </p:nvSpPr>
           <p:spPr>
             <a:xfrm>
-              <a:off x="800647" y="2994100"/>
-              <a:ext cx="10913776" cy="0"/>
+              <a:off x="797995" y="2995493"/>
+              <a:ext cx="10916428" cy="0"/>
             </a:xfrm>
             <a:custGeom>
               <a:avLst/>
               <a:pathLst>
-                <a:path w="10913776" h="0">
+                <a:path w="10916428" h="0">
                   <a:moveTo>
                     <a:pt x="0" y="0"/>
                   </a:moveTo>
                   <a:lnTo>
-                    <a:pt x="10913776" y="0"/>
+                    <a:pt x="10916428" y="0"/>
                   </a:lnTo>
                   <a:lnTo>
-                    <a:pt x="10913776" y="0"/>
+                    <a:pt x="10916428" y="0"/>
                   </a:lnTo>
                 </a:path>
               </a:pathLst>
@@ -3687,21 +3687,21 @@
           </p:nvSpPr>
           <p:spPr>
             <a:xfrm>
-              <a:off x="800647" y="2257236"/>
-              <a:ext cx="10913776" cy="0"/>
+              <a:off x="797995" y="2257710"/>
+              <a:ext cx="10916428" cy="0"/>
             </a:xfrm>
             <a:custGeom>
               <a:avLst/>
               <a:pathLst>
-                <a:path w="10913776" h="0">
+                <a:path w="10916428" h="0">
                   <a:moveTo>
                     <a:pt x="0" y="0"/>
                   </a:moveTo>
                   <a:lnTo>
-                    <a:pt x="10913776" y="0"/>
+                    <a:pt x="10916428" y="0"/>
                   </a:lnTo>
                   <a:lnTo>
-                    <a:pt x="10913776" y="0"/>
+                    <a:pt x="10916428" y="0"/>
                   </a:lnTo>
                 </a:path>
               </a:pathLst>
@@ -3730,15 +3730,15 @@
           </p:nvSpPr>
           <p:spPr>
             <a:xfrm>
-              <a:off x="1263748" y="1877752"/>
-              <a:ext cx="0" cy="3809583"/>
+              <a:off x="1261209" y="1877752"/>
+              <a:ext cx="0" cy="3814338"/>
             </a:xfrm>
             <a:custGeom>
               <a:avLst/>
               <a:pathLst>
-                <a:path w="0" h="3809583">
+                <a:path w="0" h="3814338">
                   <a:moveTo>
-                    <a:pt x="0" y="3809583"/>
+                    <a:pt x="0" y="3814338"/>
                   </a:moveTo>
                   <a:lnTo>
                     <a:pt x="0" y="0"/>
@@ -3773,15 +3773,15 @@
           </p:nvSpPr>
           <p:spPr>
             <a:xfrm>
-              <a:off x="3800597" y="1877752"/>
-              <a:ext cx="0" cy="3809583"/>
+              <a:off x="3798674" y="1877752"/>
+              <a:ext cx="0" cy="3814338"/>
             </a:xfrm>
             <a:custGeom>
               <a:avLst/>
               <a:pathLst>
-                <a:path w="0" h="3809583">
+                <a:path w="0" h="3814338">
                   <a:moveTo>
-                    <a:pt x="0" y="3809583"/>
+                    <a:pt x="0" y="3814338"/>
                   </a:moveTo>
                   <a:lnTo>
                     <a:pt x="0" y="0"/>
@@ -3816,15 +3816,15 @@
           </p:nvSpPr>
           <p:spPr>
             <a:xfrm>
-              <a:off x="6337446" y="1877752"/>
-              <a:ext cx="0" cy="3809583"/>
+              <a:off x="6336139" y="1877752"/>
+              <a:ext cx="0" cy="3814338"/>
             </a:xfrm>
             <a:custGeom>
               <a:avLst/>
               <a:pathLst>
-                <a:path w="0" h="3809583">
+                <a:path w="0" h="3814338">
                   <a:moveTo>
-                    <a:pt x="0" y="3809583"/>
+                    <a:pt x="0" y="3814338"/>
                   </a:moveTo>
                   <a:lnTo>
                     <a:pt x="0" y="0"/>
@@ -3859,15 +3859,15 @@
           </p:nvSpPr>
           <p:spPr>
             <a:xfrm>
-              <a:off x="8874294" y="1877752"/>
-              <a:ext cx="0" cy="3809583"/>
+              <a:off x="8873604" y="1877752"/>
+              <a:ext cx="0" cy="3814338"/>
             </a:xfrm>
             <a:custGeom>
               <a:avLst/>
               <a:pathLst>
-                <a:path w="0" h="3809583">
+                <a:path w="0" h="3814338">
                   <a:moveTo>
-                    <a:pt x="0" y="3809583"/>
+                    <a:pt x="0" y="3814338"/>
                   </a:moveTo>
                   <a:lnTo>
                     <a:pt x="0" y="0"/>
@@ -3902,15 +3902,15 @@
           </p:nvSpPr>
           <p:spPr>
             <a:xfrm>
-              <a:off x="11411143" y="1877752"/>
-              <a:ext cx="0" cy="3809583"/>
+              <a:off x="11411070" y="1877752"/>
+              <a:ext cx="0" cy="3814338"/>
             </a:xfrm>
             <a:custGeom>
               <a:avLst/>
               <a:pathLst>
-                <a:path w="0" h="3809583">
+                <a:path w="0" h="3814338">
                   <a:moveTo>
-                    <a:pt x="0" y="3809583"/>
+                    <a:pt x="0" y="3814338"/>
                   </a:moveTo>
                   <a:lnTo>
                     <a:pt x="0" y="0"/>
@@ -3945,21 +3945,21 @@
           </p:nvSpPr>
           <p:spPr>
             <a:xfrm>
-              <a:off x="800647" y="5573121"/>
-              <a:ext cx="10913776" cy="0"/>
+              <a:off x="797995" y="5577734"/>
+              <a:ext cx="10916428" cy="0"/>
             </a:xfrm>
             <a:custGeom>
               <a:avLst/>
               <a:pathLst>
-                <a:path w="10913776" h="0">
+                <a:path w="10916428" h="0">
                   <a:moveTo>
                     <a:pt x="0" y="0"/>
                   </a:moveTo>
                   <a:lnTo>
-                    <a:pt x="10913776" y="0"/>
+                    <a:pt x="10916428" y="0"/>
                   </a:lnTo>
                   <a:lnTo>
-                    <a:pt x="10913776" y="0"/>
+                    <a:pt x="10916428" y="0"/>
                   </a:lnTo>
                 </a:path>
               </a:pathLst>
@@ -3988,21 +3988,21 @@
           </p:nvSpPr>
           <p:spPr>
             <a:xfrm>
-              <a:off x="800647" y="4836258"/>
-              <a:ext cx="10913776" cy="0"/>
+              <a:off x="797995" y="4839951"/>
+              <a:ext cx="10916428" cy="0"/>
             </a:xfrm>
             <a:custGeom>
               <a:avLst/>
               <a:pathLst>
-                <a:path w="10913776" h="0">
+                <a:path w="10916428" h="0">
                   <a:moveTo>
                     <a:pt x="0" y="0"/>
                   </a:moveTo>
                   <a:lnTo>
-                    <a:pt x="10913776" y="0"/>
+                    <a:pt x="10916428" y="0"/>
                   </a:lnTo>
                   <a:lnTo>
-                    <a:pt x="10913776" y="0"/>
+                    <a:pt x="10916428" y="0"/>
                   </a:lnTo>
                 </a:path>
               </a:pathLst>
@@ -4031,21 +4031,21 @@
           </p:nvSpPr>
           <p:spPr>
             <a:xfrm>
-              <a:off x="800647" y="4099395"/>
-              <a:ext cx="10913776" cy="0"/>
+              <a:off x="797995" y="4102168"/>
+              <a:ext cx="10916428" cy="0"/>
             </a:xfrm>
             <a:custGeom>
               <a:avLst/>
               <a:pathLst>
-                <a:path w="10913776" h="0">
+                <a:path w="10916428" h="0">
                   <a:moveTo>
                     <a:pt x="0" y="0"/>
                   </a:moveTo>
                   <a:lnTo>
-                    <a:pt x="10913776" y="0"/>
+                    <a:pt x="10916428" y="0"/>
                   </a:lnTo>
                   <a:lnTo>
-                    <a:pt x="10913776" y="0"/>
+                    <a:pt x="10916428" y="0"/>
                   </a:lnTo>
                 </a:path>
               </a:pathLst>
@@ -4074,21 +4074,21 @@
           </p:nvSpPr>
           <p:spPr>
             <a:xfrm>
-              <a:off x="800647" y="3362531"/>
-              <a:ext cx="10913776" cy="0"/>
+              <a:off x="797995" y="3364384"/>
+              <a:ext cx="10916428" cy="0"/>
             </a:xfrm>
             <a:custGeom>
               <a:avLst/>
               <a:pathLst>
-                <a:path w="10913776" h="0">
+                <a:path w="10916428" h="0">
                   <a:moveTo>
                     <a:pt x="0" y="0"/>
                   </a:moveTo>
                   <a:lnTo>
-                    <a:pt x="10913776" y="0"/>
+                    <a:pt x="10916428" y="0"/>
                   </a:lnTo>
                   <a:lnTo>
-                    <a:pt x="10913776" y="0"/>
+                    <a:pt x="10916428" y="0"/>
                   </a:lnTo>
                 </a:path>
               </a:pathLst>
@@ -4117,21 +4117,21 @@
           </p:nvSpPr>
           <p:spPr>
             <a:xfrm>
-              <a:off x="800647" y="2625668"/>
-              <a:ext cx="10913776" cy="0"/>
+              <a:off x="797995" y="2626601"/>
+              <a:ext cx="10916428" cy="0"/>
             </a:xfrm>
             <a:custGeom>
               <a:avLst/>
               <a:pathLst>
-                <a:path w="10913776" h="0">
+                <a:path w="10916428" h="0">
                   <a:moveTo>
                     <a:pt x="0" y="0"/>
                   </a:moveTo>
                   <a:lnTo>
-                    <a:pt x="10913776" y="0"/>
+                    <a:pt x="10916428" y="0"/>
                   </a:lnTo>
                   <a:lnTo>
-                    <a:pt x="10913776" y="0"/>
+                    <a:pt x="10916428" y="0"/>
                   </a:lnTo>
                 </a:path>
               </a:pathLst>
@@ -4160,21 +4160,21 @@
           </p:nvSpPr>
           <p:spPr>
             <a:xfrm>
-              <a:off x="800647" y="1888804"/>
-              <a:ext cx="10913776" cy="0"/>
+              <a:off x="797995" y="1888818"/>
+              <a:ext cx="10916428" cy="0"/>
             </a:xfrm>
             <a:custGeom>
               <a:avLst/>
               <a:pathLst>
-                <a:path w="10913776" h="0">
+                <a:path w="10916428" h="0">
                   <a:moveTo>
                     <a:pt x="0" y="0"/>
                   </a:moveTo>
                   <a:lnTo>
-                    <a:pt x="10913776" y="0"/>
+                    <a:pt x="10916428" y="0"/>
                   </a:lnTo>
                   <a:lnTo>
-                    <a:pt x="10913776" y="0"/>
+                    <a:pt x="10916428" y="0"/>
                   </a:lnTo>
                 </a:path>
               </a:pathLst>
@@ -4203,15 +4203,15 @@
           </p:nvSpPr>
           <p:spPr>
             <a:xfrm>
-              <a:off x="2532173" y="1877752"/>
-              <a:ext cx="0" cy="3809583"/>
+              <a:off x="2529942" y="1877752"/>
+              <a:ext cx="0" cy="3814338"/>
             </a:xfrm>
             <a:custGeom>
               <a:avLst/>
               <a:pathLst>
-                <a:path w="0" h="3809583">
+                <a:path w="0" h="3814338">
                   <a:moveTo>
-                    <a:pt x="0" y="3809583"/>
+                    <a:pt x="0" y="3814338"/>
                   </a:moveTo>
                   <a:lnTo>
                     <a:pt x="0" y="0"/>
@@ -4246,15 +4246,15 @@
           </p:nvSpPr>
           <p:spPr>
             <a:xfrm>
-              <a:off x="5069021" y="1877752"/>
-              <a:ext cx="0" cy="3809583"/>
+              <a:off x="5067407" y="1877752"/>
+              <a:ext cx="0" cy="3814338"/>
             </a:xfrm>
             <a:custGeom>
               <a:avLst/>
               <a:pathLst>
-                <a:path w="0" h="3809583">
+                <a:path w="0" h="3814338">
                   <a:moveTo>
-                    <a:pt x="0" y="3809583"/>
+                    <a:pt x="0" y="3814338"/>
                   </a:moveTo>
                   <a:lnTo>
                     <a:pt x="0" y="0"/>
@@ -4289,15 +4289,15 @@
           </p:nvSpPr>
           <p:spPr>
             <a:xfrm>
-              <a:off x="7605870" y="1877752"/>
-              <a:ext cx="0" cy="3809583"/>
+              <a:off x="7604872" y="1877752"/>
+              <a:ext cx="0" cy="3814338"/>
             </a:xfrm>
             <a:custGeom>
               <a:avLst/>
               <a:pathLst>
-                <a:path w="0" h="3809583">
+                <a:path w="0" h="3814338">
                   <a:moveTo>
-                    <a:pt x="0" y="3809583"/>
+                    <a:pt x="0" y="3814338"/>
                   </a:moveTo>
                   <a:lnTo>
                     <a:pt x="0" y="0"/>
@@ -4332,15 +4332,15 @@
           </p:nvSpPr>
           <p:spPr>
             <a:xfrm>
-              <a:off x="10142719" y="1877752"/>
-              <a:ext cx="0" cy="3809583"/>
+              <a:off x="10142337" y="1877752"/>
+              <a:ext cx="0" cy="3814338"/>
             </a:xfrm>
             <a:custGeom>
               <a:avLst/>
               <a:pathLst>
-                <a:path w="0" h="3809583">
+                <a:path w="0" h="3814338">
                   <a:moveTo>
-                    <a:pt x="0" y="3809583"/>
+                    <a:pt x="0" y="3814338"/>
                   </a:moveTo>
                   <a:lnTo>
                     <a:pt x="0" y="0"/>
@@ -4375,7 +4375,7 @@
           </p:nvSpPr>
           <p:spPr>
             <a:xfrm>
-              <a:off x="4071944" y="3918947"/>
+              <a:off x="4070095" y="3921536"/>
               <a:ext cx="66150" cy="66150"/>
             </a:xfrm>
             <a:prstGeom prst="ellipse">
@@ -4410,7 +4410,7 @@
           </p:nvSpPr>
           <p:spPr>
             <a:xfrm>
-              <a:off x="4718840" y="3918947"/>
+              <a:off x="4717149" y="3921536"/>
               <a:ext cx="66150" cy="66150"/>
             </a:xfrm>
             <a:prstGeom prst="ellipse">
@@ -4445,7 +4445,7 @@
           </p:nvSpPr>
           <p:spPr>
             <a:xfrm>
-              <a:off x="3310889" y="3653676"/>
+              <a:off x="3308856" y="3655934"/>
               <a:ext cx="66150" cy="66150"/>
             </a:xfrm>
             <a:prstGeom prst="ellipse">
@@ -4480,7 +4480,7 @@
           </p:nvSpPr>
           <p:spPr>
             <a:xfrm>
-              <a:off x="5581369" y="3859998"/>
+              <a:off x="5579887" y="3862513"/>
               <a:ext cx="66150" cy="66150"/>
             </a:xfrm>
             <a:prstGeom prst="ellipse">
@@ -4515,7 +4515,7 @@
           </p:nvSpPr>
           <p:spPr>
             <a:xfrm>
-              <a:off x="6152160" y="4257904"/>
+              <a:off x="6150816" y="4260916"/>
               <a:ext cx="66150" cy="66150"/>
             </a:xfrm>
             <a:prstGeom prst="ellipse">
@@ -4550,7 +4550,7 @@
           </p:nvSpPr>
           <p:spPr>
             <a:xfrm>
-              <a:off x="6202897" y="4346328"/>
+              <a:off x="6201566" y="4349450"/>
               <a:ext cx="66150" cy="66150"/>
             </a:xfrm>
             <a:prstGeom prst="ellipse">
@@ -4585,7 +4585,7 @@
           </p:nvSpPr>
           <p:spPr>
             <a:xfrm>
-              <a:off x="6481950" y="4906344"/>
+              <a:off x="6480687" y="4910165"/>
               <a:ext cx="66150" cy="66150"/>
             </a:xfrm>
             <a:prstGeom prst="ellipse">
@@ -4620,7 +4620,7 @@
           </p:nvSpPr>
           <p:spPr>
             <a:xfrm>
-              <a:off x="5517948" y="3417880"/>
+              <a:off x="5516450" y="3419843"/>
               <a:ext cx="66150" cy="66150"/>
             </a:xfrm>
             <a:prstGeom prst="ellipse">
@@ -4655,7 +4655,7 @@
           </p:nvSpPr>
           <p:spPr>
             <a:xfrm>
-              <a:off x="5416474" y="3653676"/>
+              <a:off x="5414952" y="3655934"/>
               <a:ext cx="66150" cy="66150"/>
             </a:xfrm>
             <a:prstGeom prst="ellipse">
@@ -4690,7 +4690,7 @@
           </p:nvSpPr>
           <p:spPr>
             <a:xfrm>
-              <a:off x="6152160" y="4184218"/>
+              <a:off x="6150816" y="4187138"/>
               <a:ext cx="66150" cy="66150"/>
             </a:xfrm>
             <a:prstGeom prst="ellipse">
@@ -4725,7 +4725,7 @@
           </p:nvSpPr>
           <p:spPr>
             <a:xfrm>
-              <a:off x="6152160" y="4390540"/>
+              <a:off x="6150816" y="4393717"/>
               <a:ext cx="66150" cy="66150"/>
             </a:xfrm>
             <a:prstGeom prst="ellipse">
@@ -4760,7 +4760,7 @@
           </p:nvSpPr>
           <p:spPr>
             <a:xfrm>
-              <a:off x="7750375" y="4596861"/>
+              <a:off x="7749419" y="4600296"/>
               <a:ext cx="66150" cy="66150"/>
             </a:xfrm>
             <a:prstGeom prst="ellipse">
@@ -4795,7 +4795,7 @@
           </p:nvSpPr>
           <p:spPr>
             <a:xfrm>
-              <a:off x="6887846" y="4464226"/>
+              <a:off x="6886681" y="4467495"/>
               <a:ext cx="66150" cy="66150"/>
             </a:xfrm>
             <a:prstGeom prst="ellipse">
@@ -4830,7 +4830,7 @@
           </p:nvSpPr>
           <p:spPr>
             <a:xfrm>
-              <a:off x="7014688" y="4773709"/>
+              <a:off x="7013555" y="4777364"/>
               <a:ext cx="66150" cy="66150"/>
             </a:xfrm>
             <a:prstGeom prst="ellipse">
@@ -4865,7 +4865,7 @@
           </p:nvSpPr>
           <p:spPr>
             <a:xfrm>
-              <a:off x="10743856" y="5481097"/>
+              <a:off x="10743628" y="5485636"/>
               <a:ext cx="66150" cy="66150"/>
             </a:xfrm>
             <a:prstGeom prst="ellipse">
@@ -4900,7 +4900,7 @@
           </p:nvSpPr>
           <p:spPr>
             <a:xfrm>
-              <a:off x="11185268" y="5481097"/>
+              <a:off x="11185147" y="5485636"/>
               <a:ext cx="66150" cy="66150"/>
             </a:xfrm>
             <a:prstGeom prst="ellipse">
@@ -4935,7 +4935,7 @@
           </p:nvSpPr>
           <p:spPr>
             <a:xfrm>
-              <a:off x="10984857" y="4847395"/>
+              <a:off x="10984687" y="4851143"/>
               <a:ext cx="66150" cy="66150"/>
             </a:xfrm>
             <a:prstGeom prst="ellipse">
@@ -4970,7 +4970,7 @@
           </p:nvSpPr>
           <p:spPr>
             <a:xfrm>
-              <a:off x="3006467" y="2238898"/>
+              <a:off x="3004360" y="2239390"/>
               <a:ext cx="66150" cy="66150"/>
             </a:xfrm>
             <a:prstGeom prst="ellipse">
@@ -5005,7 +5005,7 @@
           </p:nvSpPr>
           <p:spPr>
             <a:xfrm>
-              <a:off x="1522411" y="2533644"/>
+              <a:off x="1519943" y="2534504"/>
               <a:ext cx="66150" cy="66150"/>
             </a:xfrm>
             <a:prstGeom prst="ellipse">
@@ -5040,7 +5040,7 @@
           </p:nvSpPr>
           <p:spPr>
             <a:xfrm>
-              <a:off x="2080518" y="2017839"/>
+              <a:off x="2078185" y="2018056"/>
               <a:ext cx="66150" cy="66150"/>
             </a:xfrm>
             <a:prstGeom prst="ellipse">
@@ -5075,7 +5075,7 @@
           </p:nvSpPr>
           <p:spPr>
             <a:xfrm>
-              <a:off x="3678732" y="3845261"/>
+              <a:off x="3676788" y="3847758"/>
               <a:ext cx="66150" cy="66150"/>
             </a:xfrm>
             <a:prstGeom prst="ellipse">
@@ -5110,7 +5110,7 @@
           </p:nvSpPr>
           <p:spPr>
             <a:xfrm>
-              <a:off x="6355108" y="4729497"/>
+              <a:off x="6353814" y="4733097"/>
               <a:ext cx="66150" cy="66150"/>
             </a:xfrm>
             <a:prstGeom prst="ellipse">
@@ -5145,7 +5145,7 @@
           </p:nvSpPr>
           <p:spPr>
             <a:xfrm>
-              <a:off x="6139476" y="4773709"/>
+              <a:off x="6138129" y="4777364"/>
               <a:ext cx="66150" cy="66150"/>
             </a:xfrm>
             <a:prstGeom prst="ellipse">
@@ -5180,7 +5180,7 @@
           </p:nvSpPr>
           <p:spPr>
             <a:xfrm>
-              <a:off x="7166899" y="5053717"/>
+              <a:off x="7165802" y="5057722"/>
               <a:ext cx="66150" cy="66150"/>
             </a:xfrm>
             <a:prstGeom prst="ellipse">
@@ -5215,7 +5215,7 @@
           </p:nvSpPr>
           <p:spPr>
             <a:xfrm>
-              <a:off x="7179584" y="4184218"/>
+              <a:off x="7178490" y="4187138"/>
               <a:ext cx="66150" cy="66150"/>
             </a:xfrm>
             <a:prstGeom prst="ellipse">
@@ -5250,7 +5250,7 @@
           </p:nvSpPr>
           <p:spPr>
             <a:xfrm>
-              <a:off x="2334203" y="2990499"/>
+              <a:off x="2331931" y="2991929"/>
               <a:ext cx="66150" cy="66150"/>
             </a:xfrm>
             <a:prstGeom prst="ellipse">
@@ -5285,7 +5285,7 @@
           </p:nvSpPr>
           <p:spPr>
             <a:xfrm>
-              <a:off x="2854257" y="3182084"/>
+              <a:off x="2852112" y="3183753"/>
               <a:ext cx="66150" cy="66150"/>
             </a:xfrm>
             <a:prstGeom prst="ellipse">
@@ -5320,7 +5320,7 @@
           </p:nvSpPr>
           <p:spPr>
             <a:xfrm>
-              <a:off x="1263652" y="2533644"/>
+              <a:off x="1261121" y="2534504"/>
               <a:ext cx="66150" cy="66150"/>
             </a:xfrm>
             <a:prstGeom prst="ellipse">
@@ -5355,7 +5355,7 @@
           </p:nvSpPr>
           <p:spPr>
             <a:xfrm>
-              <a:off x="5467211" y="4685285"/>
+              <a:off x="5465701" y="4688830"/>
               <a:ext cx="66150" cy="66150"/>
             </a:xfrm>
             <a:prstGeom prst="ellipse">
@@ -5390,7 +5390,7 @@
           </p:nvSpPr>
           <p:spPr>
             <a:xfrm>
-              <a:off x="4452471" y="4110531"/>
+              <a:off x="4450715" y="4113360"/>
               <a:ext cx="66150" cy="66150"/>
             </a:xfrm>
             <a:prstGeom prst="ellipse">
@@ -5425,7 +5425,7 @@
           </p:nvSpPr>
           <p:spPr>
             <a:xfrm>
-              <a:off x="6481950" y="4803183"/>
+              <a:off x="6480687" y="4806876"/>
               <a:ext cx="66150" cy="66150"/>
             </a:xfrm>
             <a:prstGeom prst="ellipse">
@@ -5460,7 +5460,7 @@
           </p:nvSpPr>
           <p:spPr>
             <a:xfrm>
-              <a:off x="4477840" y="3859998"/>
+              <a:off x="4476089" y="3862513"/>
               <a:ext cx="66150" cy="66150"/>
             </a:xfrm>
             <a:prstGeom prst="ellipse">
@@ -5495,7 +5495,7 @@
           </p:nvSpPr>
           <p:spPr>
             <a:xfrm>
-              <a:off x="608355" y="5533574"/>
+              <a:off x="605703" y="5538186"/>
               <a:ext cx="129661" cy="79095"/>
             </a:xfrm>
             <a:prstGeom prst="rect">
@@ -5541,7 +5541,7 @@
           </p:nvSpPr>
           <p:spPr>
             <a:xfrm>
-              <a:off x="608355" y="4796710"/>
+              <a:off x="605703" y="4800403"/>
               <a:ext cx="129661" cy="79095"/>
             </a:xfrm>
             <a:prstGeom prst="rect">
@@ -5587,7 +5587,7 @@
           </p:nvSpPr>
           <p:spPr>
             <a:xfrm>
-              <a:off x="608355" y="4059847"/>
+              <a:off x="605703" y="4062620"/>
               <a:ext cx="129661" cy="79095"/>
             </a:xfrm>
             <a:prstGeom prst="rect">
@@ -5633,7 +5633,7 @@
           </p:nvSpPr>
           <p:spPr>
             <a:xfrm>
-              <a:off x="608355" y="3322983"/>
+              <a:off x="605703" y="3324837"/>
               <a:ext cx="129661" cy="79095"/>
             </a:xfrm>
             <a:prstGeom prst="rect">
@@ -5679,7 +5679,7 @@
           </p:nvSpPr>
           <p:spPr>
             <a:xfrm>
-              <a:off x="608355" y="2586120"/>
+              <a:off x="605703" y="2587054"/>
               <a:ext cx="129661" cy="79095"/>
             </a:xfrm>
             <a:prstGeom prst="rect">
@@ -5725,7 +5725,7 @@
           </p:nvSpPr>
           <p:spPr>
             <a:xfrm>
-              <a:off x="608355" y="1849257"/>
+              <a:off x="605703" y="1849270"/>
               <a:ext cx="129661" cy="79095"/>
             </a:xfrm>
             <a:prstGeom prst="rect">
@@ -5771,7 +5771,7 @@
           </p:nvSpPr>
           <p:spPr>
             <a:xfrm>
-              <a:off x="765852" y="5573121"/>
+              <a:off x="763200" y="5577734"/>
               <a:ext cx="34794" cy="0"/>
             </a:xfrm>
             <a:custGeom>
@@ -5811,7 +5811,7 @@
           </p:nvSpPr>
           <p:spPr>
             <a:xfrm>
-              <a:off x="765852" y="4836258"/>
+              <a:off x="763200" y="4839951"/>
               <a:ext cx="34794" cy="0"/>
             </a:xfrm>
             <a:custGeom>
@@ -5851,7 +5851,7 @@
           </p:nvSpPr>
           <p:spPr>
             <a:xfrm>
-              <a:off x="765852" y="4099395"/>
+              <a:off x="763200" y="4102168"/>
               <a:ext cx="34794" cy="0"/>
             </a:xfrm>
             <a:custGeom>
@@ -5891,7 +5891,7 @@
           </p:nvSpPr>
           <p:spPr>
             <a:xfrm>
-              <a:off x="765852" y="3362531"/>
+              <a:off x="763200" y="3364384"/>
               <a:ext cx="34794" cy="0"/>
             </a:xfrm>
             <a:custGeom>
@@ -5931,7 +5931,7 @@
           </p:nvSpPr>
           <p:spPr>
             <a:xfrm>
-              <a:off x="765852" y="2625668"/>
+              <a:off x="763200" y="2626601"/>
               <a:ext cx="34794" cy="0"/>
             </a:xfrm>
             <a:custGeom>
@@ -5971,7 +5971,7 @@
           </p:nvSpPr>
           <p:spPr>
             <a:xfrm>
-              <a:off x="765852" y="1888804"/>
+              <a:off x="763200" y="1888818"/>
               <a:ext cx="34794" cy="0"/>
             </a:xfrm>
             <a:custGeom>
@@ -6011,7 +6011,7 @@
           </p:nvSpPr>
           <p:spPr>
             <a:xfrm>
-              <a:off x="2532173" y="5687335"/>
+              <a:off x="2529942" y="5692090"/>
               <a:ext cx="0" cy="34794"/>
             </a:xfrm>
             <a:custGeom>
@@ -6051,7 +6051,7 @@
           </p:nvSpPr>
           <p:spPr>
             <a:xfrm>
-              <a:off x="5069021" y="5687335"/>
+              <a:off x="5067407" y="5692090"/>
               <a:ext cx="0" cy="34794"/>
             </a:xfrm>
             <a:custGeom>
@@ -6091,7 +6091,7 @@
           </p:nvSpPr>
           <p:spPr>
             <a:xfrm>
-              <a:off x="7605870" y="5687335"/>
+              <a:off x="7604872" y="5692090"/>
               <a:ext cx="0" cy="34794"/>
             </a:xfrm>
             <a:custGeom>
@@ -6131,7 +6131,7 @@
           </p:nvSpPr>
           <p:spPr>
             <a:xfrm>
-              <a:off x="10142719" y="5687335"/>
+              <a:off x="10142337" y="5692090"/>
               <a:ext cx="0" cy="34794"/>
             </a:xfrm>
             <a:custGeom>
@@ -6171,7 +6171,7 @@
           </p:nvSpPr>
           <p:spPr>
             <a:xfrm>
-              <a:off x="2499757" y="5749965"/>
+              <a:off x="2497526" y="5754720"/>
               <a:ext cx="64830" cy="79095"/>
             </a:xfrm>
             <a:prstGeom prst="rect">
@@ -6217,7 +6217,7 @@
           </p:nvSpPr>
           <p:spPr>
             <a:xfrm>
-              <a:off x="5036606" y="5749965"/>
+              <a:off x="5034991" y="5754720"/>
               <a:ext cx="64830" cy="79095"/>
             </a:xfrm>
             <a:prstGeom prst="rect">
@@ -6263,7 +6263,7 @@
           </p:nvSpPr>
           <p:spPr>
             <a:xfrm>
-              <a:off x="7573455" y="5749965"/>
+              <a:off x="7572456" y="5754720"/>
               <a:ext cx="64830" cy="79095"/>
             </a:xfrm>
             <a:prstGeom prst="rect">
@@ -6309,7 +6309,7 @@
           </p:nvSpPr>
           <p:spPr>
             <a:xfrm>
-              <a:off x="10110303" y="5749965"/>
+              <a:off x="10109921" y="5754720"/>
               <a:ext cx="64830" cy="79095"/>
             </a:xfrm>
             <a:prstGeom prst="rect">
@@ -6355,7 +6355,7 @@
           </p:nvSpPr>
           <p:spPr>
             <a:xfrm>
-              <a:off x="6183286" y="5890739"/>
+              <a:off x="6181960" y="5893391"/>
               <a:ext cx="148498" cy="98938"/>
             </a:xfrm>
             <a:prstGeom prst="rect">
@@ -6401,7 +6401,7 @@
           </p:nvSpPr>
           <p:spPr>
             <a:xfrm rot="-5400000">
-              <a:off x="340342" y="3733074"/>
+              <a:off x="340342" y="3735452"/>
               <a:ext cx="300380" cy="98938"/>
             </a:xfrm>
             <a:prstGeom prst="rect">

</xml_diff>